<commit_message>
feat(repro): add final no-label artifacts
</commit_message>
<xml_diff>
--- a/outputs/final_project/NHTS_LLM_Event_Adaptation_Optimized_Presentation.pptx
+++ b/outputs/final_project/NHTS_LLM_Event_Adaptation_Optimized_Presentation.pptx
@@ -3245,7 +3245,7 @@
               </a:defRPr>
             </a:pPr>
             <a:r>
-              <a:t>-42.8%</a:t>
+              <a:t>-42.3%</a:t>
             </a:r>
           </a:p>
           <a:p>
@@ -3258,7 +3258,7 @@
               </a:defRPr>
             </a:pPr>
             <a:r>
-              <a:t>LLM prior vs historical</a:t>
+              <a:t>primary gated rule</a:t>
             </a:r>
           </a:p>
         </p:txBody>
@@ -4876,6 +4876,22 @@
               </a:defRPr>
             </a:pPr>
             <a:r>
+              <a:t>Do not claim the best-MAE alpha was selected without looking at 2022 evaluation; treat it as sensitivity.</a:t>
+            </a:r>
+          </a:p>
+          <a:p>
+            <a:pPr>
+              <a:spcAft>
+                <a:spcPts val="800"/>
+              </a:spcAft>
+              <a:defRPr sz="2300" b="0">
+                <a:solidFill>
+                  <a:srgbClr val="0F172A"/>
+                </a:solidFill>
+                <a:latin typeface="Microsoft YaHei"/>
+              </a:defRPr>
+            </a:pPr>
+            <a:r>
               <a:t>Do not compare trip-count MAE with trip-level mode-classification accuracy.</a:t>
             </a:r>
           </a:p>
@@ -5097,7 +5113,7 @@
               </a:defRPr>
             </a:pPr>
             <a:r>
-              <a:t>Trip-count error</a:t>
+              <a:t>Primary trip-count rule</a:t>
             </a:r>
           </a:p>
           <a:p>
@@ -5110,7 +5126,7 @@
               </a:defRPr>
             </a:pPr>
             <a:r>
-              <a:t>-42.8%</a:t>
+              <a:t>-42.3%</a:t>
             </a:r>
           </a:p>
           <a:p>
@@ -5123,7 +5139,7 @@
               </a:defRPr>
             </a:pPr>
             <a:r>
-              <a:t>weighted MAE reduction</a:t>
+              <a:t>gated weighted MAE reduction</a:t>
             </a:r>
           </a:p>
         </p:txBody>
@@ -6847,7 +6863,7 @@
                         </a:defRPr>
                       </a:pPr>
                       <a:r>
-                        <a:t>Best MAE</a:t>
+                        <a:t>Best-MAE sensitivity</a:t>
                       </a:r>
                     </a:p>
                   </a:txBody>
@@ -6929,7 +6945,7 @@
                         </a:defRPr>
                       </a:pPr>
                       <a:r>
-                        <a:t>Best bias/R2 tradeoff</a:t>
+                        <a:t>Primary no-label rule</a:t>
                       </a:r>
                     </a:p>
                   </a:txBody>
@@ -7894,7 +7910,7 @@
               </a:defRPr>
             </a:pPr>
             <a:r>
-              <a:t>Best MAE: 2.482, a 42.8% reduction.</a:t>
+              <a:t>Primary no-label gated rule: MAE 2.502, bias -0.023.</a:t>
             </a:r>
           </a:p>
           <a:p>
@@ -7910,7 +7926,7 @@
               </a:defRPr>
             </a:pPr>
             <a:r>
-              <a:t>Best bias/R2: gated correction bias -0.023, R2 0.248.</a:t>
+              <a:t>Best-MAE sensitivity row: MAE 2.482, a 42.8% reduction.</a:t>
             </a:r>
           </a:p>
         </p:txBody>

</xml_diff>

<commit_message>
docs(story): strengthen travel behavior framing
</commit_message>
<xml_diff>
--- a/outputs/final_project/NHTS_LLM_Event_Adaptation_Optimized_Presentation.pptx
+++ b/outputs/final_project/NHTS_LLM_Event_Adaptation_Optimized_Presentation.pptx
@@ -3141,7 +3141,7 @@
               </a:defRPr>
             </a:pPr>
             <a:r>
-              <a:t>Label-Free LLM Event Adaptation</a:t>
+              <a:t>Pandemic-Aware Household Travel Behavior Prediction</a:t>
             </a:r>
           </a:p>
         </p:txBody>
@@ -3177,7 +3177,7 @@
               </a:defRPr>
             </a:pPr>
             <a:r>
-              <a:t>Predicting post-pandemic household mobility without 2022 training labels</a:t>
+              <a:t>LLM event priors for label-free adaptation under post-pandemic shift</a:t>
             </a:r>
           </a:p>
         </p:txBody>
@@ -3554,7 +3554,7 @@
               </a:defRPr>
             </a:pPr>
             <a:r>
-              <a:t>LLM helps the transit component, but the effect is auxiliary</a:t>
+              <a:t>LLM helps the transit component of household behavior</a:t>
             </a:r>
           </a:p>
         </p:txBody>
@@ -3669,7 +3669,7 @@
               </a:defRPr>
             </a:pPr>
             <a:r>
-              <a:t>Overall mode-composition gain is small, so this belongs as supporting evidence.</a:t>
+              <a:t>Overall mode-composition gain is small, while the transit component shows a clearer pandemic-related signal.</a:t>
             </a:r>
           </a:p>
         </p:txBody>
@@ -4671,6 +4671,22 @@
               </a:defRPr>
             </a:pPr>
             <a:r>
+              <a:t>The LLM-only pressure baseline improves over naive history but is weaker than the hybrid model.</a:t>
+            </a:r>
+          </a:p>
+          <a:p>
+            <a:pPr>
+              <a:spcAft>
+                <a:spcPts val="800"/>
+              </a:spcAft>
+              <a:defRPr sz="2200" b="0">
+                <a:solidFill>
+                  <a:srgbClr val="0F172A"/>
+                </a:solidFill>
+                <a:latin typeface="Microsoft YaHei"/>
+              </a:defRPr>
+            </a:pPr>
+            <a:r>
               <a:t>Global controls show that broad event downscaling is strong.</a:t>
             </a:r>
           </a:p>
@@ -4892,7 +4908,7 @@
               </a:defRPr>
             </a:pPr>
             <a:r>
-              <a:t>Do not compare trip-count MAE with trip-level mode-classification accuracy.</a:t>
+              <a:t>Present trip generation and mode composition as two household-level outputs, not as separate projects.</a:t>
             </a:r>
           </a:p>
           <a:p>
@@ -4908,7 +4924,7 @@
               </a:defRPr>
             </a:pPr>
             <a:r>
-              <a:t>Mode composition is an auxiliary extension; the main validated result is CNTTDHH adaptation.</a:t>
+              <a:t>Mode composition is weaker overall than trip-count adaptation, but it adds the mode-structure dimension.</a:t>
             </a:r>
           </a:p>
           <a:p>
@@ -5301,7 +5317,7 @@
               </a:defRPr>
             </a:pPr>
             <a:r>
-              <a:t>auxiliary mode result</a:t>
+              <a:t>mode-structure result</a:t>
             </a:r>
           </a:p>
         </p:txBody>
@@ -5454,7 +5470,7 @@
               </a:defRPr>
             </a:pPr>
             <a:r>
-              <a:t>Two related tasks, two different metric families</a:t>
+              <a:t>A household-level travel behavior prediction system</a:t>
             </a:r>
           </a:p>
         </p:txBody>
@@ -5535,7 +5551,7 @@
                         </a:defRPr>
                       </a:pPr>
                       <a:r>
-                        <a:t>Task</a:t>
+                        <a:t>Output</a:t>
                       </a:r>
                     </a:p>
                   </a:txBody>
@@ -5631,7 +5647,7 @@
                         </a:defRPr>
                       </a:pPr>
                       <a:r>
-                        <a:t>Role in story</a:t>
+                        <a:t>Role in system</a:t>
                       </a:r>
                     </a:p>
                   </a:txBody>
@@ -5737,7 +5753,7 @@
                         </a:defRPr>
                       </a:pPr>
                       <a:r>
-                        <a:t>Main claim</a:t>
+                        <a:t>How many trips</a:t>
                       </a:r>
                     </a:p>
                   </a:txBody>
@@ -5839,7 +5855,7 @@
                         </a:defRPr>
                       </a:pPr>
                       <a:r>
-                        <a:t>Auxiliary evidence</a:t>
+                        <a:t>How trips are distributed</a:t>
                       </a:r>
                     </a:p>
                   </a:txBody>
@@ -5861,7 +5877,7 @@
                         </a:defRPr>
                       </a:pPr>
                       <a:r>
-                        <a:t>Trip-level mode</a:t>
+                        <a:t>Mode-specific trips</a:t>
                       </a:r>
                     </a:p>
                   </a:txBody>
@@ -5881,7 +5897,7 @@
                         </a:defRPr>
                       </a:pPr>
                       <a:r>
-                        <a:t>TRPTRANS</a:t>
+                        <a:t>Trips by mode</a:t>
                       </a:r>
                     </a:p>
                   </a:txBody>
@@ -5901,7 +5917,7 @@
                         </a:defRPr>
                       </a:pPr>
                       <a:r>
-                        <a:t>Trip</a:t>
+                        <a:t>Household</a:t>
                       </a:r>
                     </a:p>
                   </a:txBody>
@@ -5921,7 +5937,7 @@
                         </a:defRPr>
                       </a:pPr>
                       <a:r>
-                        <a:t>Accuracy / F1</a:t>
+                        <a:t>Derived count error</a:t>
                       </a:r>
                     </a:p>
                   </a:txBody>
@@ -5941,7 +5957,7 @@
                         </a:defRPr>
                       </a:pPr>
                       <a:r>
-                        <a:t>Different task</a:t>
+                        <a:t>How many trips by each mode</a:t>
                       </a:r>
                     </a:p>
                   </a:txBody>
@@ -5986,7 +6002,7 @@
               </a:defRPr>
             </a:pPr>
             <a:r>
-              <a:t>We do not compare regression MAE with trip-level classification accuracy.</a:t>
+              <a:t>The project predicts household travel behavior as trip volume plus mode structure.</a:t>
             </a:r>
           </a:p>
           <a:p>
@@ -6002,7 +6018,7 @@
               </a:defRPr>
             </a:pPr>
             <a:r>
-              <a:t>The main contribution is label-free adaptation under a 2022 event shift.</a:t>
+              <a:t>The LLM contribution is label-free event adaptation under a 2022 pandemic shift.</a:t>
             </a:r>
           </a:p>
         </p:txBody>
@@ -6362,7 +6378,7 @@
                 <a:gridCol w="2766060"/>
                 <a:gridCol w="2766060"/>
               </a:tblGrid>
-              <a:tr h="555171">
+              <a:tr h="485775">
                 <a:tc>
                   <a:txBody>
                     <a:bodyPr/>
@@ -6460,7 +6476,7 @@
                   </a:tcPr>
                 </a:tc>
               </a:tr>
-              <a:tr h="555171">
+              <a:tr h="485775">
                 <a:tc>
                   <a:txBody>
                     <a:bodyPr/>
@@ -6542,7 +6558,7 @@
                   <a:tcPr marL="36576" marR="36576"/>
                 </a:tc>
               </a:tr>
-              <a:tr h="555171">
+              <a:tr h="485775">
                 <a:tc>
                   <a:txBody>
                     <a:bodyPr/>
@@ -6624,7 +6640,7 @@
                   <a:tcPr marL="36576" marR="36576"/>
                 </a:tc>
               </a:tr>
-              <a:tr h="555171">
+              <a:tr h="485775">
                 <a:tc>
                   <a:txBody>
                     <a:bodyPr/>
@@ -6639,7 +6655,7 @@
                         </a:defRPr>
                       </a:pPr>
                       <a:r>
-                        <a:t>Global event prior</a:t>
+                        <a:t>LLM-only pressure</a:t>
                       </a:r>
                     </a:p>
                   </a:txBody>
@@ -6679,7 +6695,7 @@
                         </a:defRPr>
                       </a:pPr>
                       <a:r>
-                        <a:t>Only global mean</a:t>
+                        <a:t>LLM only</a:t>
                       </a:r>
                     </a:p>
                   </a:txBody>
@@ -6699,14 +6715,14 @@
                         </a:defRPr>
                       </a:pPr>
                       <a:r>
-                        <a:t>Event-level downscaling control</a:t>
+                        <a:t>No household predictor</a:t>
                       </a:r>
                     </a:p>
                   </a:txBody>
                   <a:tcPr marL="36576" marR="36576"/>
                 </a:tc>
               </a:tr>
-              <a:tr h="555171">
+              <a:tr h="485775">
                 <a:tc>
                   <a:txBody>
                     <a:bodyPr/>
@@ -6721,7 +6737,7 @@
                         </a:defRPr>
                       </a:pPr>
                       <a:r>
-                        <a:t>Random prior control</a:t>
+                        <a:t>Global event prior</a:t>
                       </a:r>
                     </a:p>
                   </a:txBody>
@@ -6761,7 +6777,7 @@
                         </a:defRPr>
                       </a:pPr>
                       <a:r>
-                        <a:t>Shuffled scores</a:t>
+                        <a:t>Only global mean</a:t>
                       </a:r>
                     </a:p>
                   </a:txBody>
@@ -6781,14 +6797,14 @@
                         </a:defRPr>
                       </a:pPr>
                       <a:r>
-                        <a:t>Negative control</a:t>
+                        <a:t>Event-level downscaling control</a:t>
                       </a:r>
                     </a:p>
                   </a:txBody>
                   <a:tcPr marL="36576" marR="36576"/>
                 </a:tc>
               </a:tr>
-              <a:tr h="555171">
+              <a:tr h="485775">
                 <a:tc>
                   <a:txBody>
                     <a:bodyPr/>
@@ -6803,7 +6819,7 @@
                         </a:defRPr>
                       </a:pPr>
                       <a:r>
-                        <a:t>LLM trip suppression</a:t>
+                        <a:t>Random prior control</a:t>
                       </a:r>
                     </a:p>
                   </a:txBody>
@@ -6843,7 +6859,7 @@
                         </a:defRPr>
                       </a:pPr>
                       <a:r>
-                        <a:t>Cohort-specific</a:t>
+                        <a:t>Shuffled scores</a:t>
                       </a:r>
                     </a:p>
                   </a:txBody>
@@ -6863,6 +6879,88 @@
                         </a:defRPr>
                       </a:pPr>
                       <a:r>
+                        <a:t>Negative control</a:t>
+                      </a:r>
+                    </a:p>
+                  </a:txBody>
+                  <a:tcPr marL="36576" marR="36576"/>
+                </a:tc>
+              </a:tr>
+              <a:tr h="485775">
+                <a:tc>
+                  <a:txBody>
+                    <a:bodyPr/>
+                    <a:lstStyle/>
+                    <a:p>
+                      <a:pPr algn="l">
+                        <a:defRPr sz="1000" b="0">
+                          <a:solidFill>
+                            <a:srgbClr val="0F172A"/>
+                          </a:solidFill>
+                          <a:latin typeface="Microsoft YaHei"/>
+                        </a:defRPr>
+                      </a:pPr>
+                      <a:r>
+                        <a:t>LLM trip suppression</a:t>
+                      </a:r>
+                    </a:p>
+                  </a:txBody>
+                  <a:tcPr marL="36576" marR="36576"/>
+                </a:tc>
+                <a:tc>
+                  <a:txBody>
+                    <a:bodyPr/>
+                    <a:lstStyle/>
+                    <a:p>
+                      <a:pPr algn="ctr">
+                        <a:defRPr sz="1000" b="0">
+                          <a:solidFill>
+                            <a:srgbClr val="0F172A"/>
+                          </a:solidFill>
+                          <a:latin typeface="Microsoft YaHei"/>
+                        </a:defRPr>
+                      </a:pPr>
+                      <a:r>
+                        <a:t>No</a:t>
+                      </a:r>
+                    </a:p>
+                  </a:txBody>
+                  <a:tcPr marL="36576" marR="36576"/>
+                </a:tc>
+                <a:tc>
+                  <a:txBody>
+                    <a:bodyPr/>
+                    <a:lstStyle/>
+                    <a:p>
+                      <a:pPr algn="ctr">
+                        <a:defRPr sz="1000" b="0">
+                          <a:solidFill>
+                            <a:srgbClr val="0F172A"/>
+                          </a:solidFill>
+                          <a:latin typeface="Microsoft YaHei"/>
+                        </a:defRPr>
+                      </a:pPr>
+                      <a:r>
+                        <a:t>Cohort-specific</a:t>
+                      </a:r>
+                    </a:p>
+                  </a:txBody>
+                  <a:tcPr marL="36576" marR="36576"/>
+                </a:tc>
+                <a:tc>
+                  <a:txBody>
+                    <a:bodyPr/>
+                    <a:lstStyle/>
+                    <a:p>
+                      <a:pPr algn="ctr">
+                        <a:defRPr sz="1000" b="0">
+                          <a:solidFill>
+                            <a:srgbClr val="0F172A"/>
+                          </a:solidFill>
+                          <a:latin typeface="Microsoft YaHei"/>
+                        </a:defRPr>
+                      </a:pPr>
+                      <a:r>
                         <a:t>Best-MAE sensitivity</a:t>
                       </a:r>
                     </a:p>
@@ -6870,7 +6968,7 @@
                   <a:tcPr marL="36576" marR="36576"/>
                 </a:tc>
               </a:tr>
-              <a:tr h="555174">
+              <a:tr h="485775">
                 <a:tc>
                   <a:txBody>
                     <a:bodyPr/>
@@ -7116,7 +7214,7 @@
                 <a:gridCol w="1844040"/>
                 <a:gridCol w="1844040"/>
               </a:tblGrid>
-              <a:tr h="548640">
+              <a:tr h="470262">
                 <a:tc>
                   <a:txBody>
                     <a:bodyPr/>
@@ -7262,7 +7360,7 @@
                   </a:tcPr>
                 </a:tc>
               </a:tr>
-              <a:tr h="548640">
+              <a:tr h="470262">
                 <a:tc>
                   <a:txBody>
                     <a:bodyPr/>
@@ -7384,7 +7482,7 @@
                   <a:tcPr marL="36576" marR="36576"/>
                 </a:tc>
               </a:tr>
-              <a:tr h="548640">
+              <a:tr h="470262">
                 <a:tc>
                   <a:txBody>
                     <a:bodyPr/>
@@ -7506,7 +7604,7 @@
                   <a:tcPr marL="36576" marR="36576"/>
                 </a:tc>
               </a:tr>
-              <a:tr h="548640">
+              <a:tr h="470262">
                 <a:tc>
                   <a:txBody>
                     <a:bodyPr/>
@@ -7521,7 +7619,7 @@
                         </a:defRPr>
                       </a:pPr>
                       <a:r>
-                        <a:t>Random prior control</a:t>
+                        <a:t>LLM-only pressure</a:t>
                       </a:r>
                     </a:p>
                   </a:txBody>
@@ -7541,7 +7639,7 @@
                         </a:defRPr>
                       </a:pPr>
                       <a:r>
-                        <a:t>2.647</a:t>
+                        <a:t>2.718</a:t>
                       </a:r>
                     </a:p>
                   </a:txBody>
@@ -7561,7 +7659,7 @@
                         </a:defRPr>
                       </a:pPr>
                       <a:r>
-                        <a:t>3.881</a:t>
+                        <a:t>3.988</a:t>
                       </a:r>
                     </a:p>
                   </a:txBody>
@@ -7581,7 +7679,7 @@
                         </a:defRPr>
                       </a:pPr>
                       <a:r>
-                        <a:t>-0.637</a:t>
+                        <a:t>-0.373</a:t>
                       </a:r>
                     </a:p>
                   </a:txBody>
@@ -7601,7 +7699,7 @@
                         </a:defRPr>
                       </a:pPr>
                       <a:r>
-                        <a:t>0.128</a:t>
+                        <a:t>0.079</a:t>
                       </a:r>
                     </a:p>
                   </a:txBody>
@@ -7621,14 +7719,14 @@
                         </a:defRPr>
                       </a:pPr>
                       <a:r>
-                        <a:t>39.0%</a:t>
+                        <a:t>37.4%</a:t>
                       </a:r>
                     </a:p>
                   </a:txBody>
                   <a:tcPr marL="36576" marR="36576"/>
                 </a:tc>
               </a:tr>
-              <a:tr h="548640">
+              <a:tr h="470262">
                 <a:tc>
                   <a:txBody>
                     <a:bodyPr/>
@@ -7643,7 +7741,7 @@
                         </a:defRPr>
                       </a:pPr>
                       <a:r>
-                        <a:t>LLM trip suppression</a:t>
+                        <a:t>Random prior control</a:t>
                       </a:r>
                     </a:p>
                   </a:txBody>
@@ -7663,7 +7761,7 @@
                         </a:defRPr>
                       </a:pPr>
                       <a:r>
-                        <a:t>2.482</a:t>
+                        <a:t>2.647</a:t>
                       </a:r>
                     </a:p>
                   </a:txBody>
@@ -7683,7 +7781,7 @@
                         </a:defRPr>
                       </a:pPr>
                       <a:r>
-                        <a:t>3.660</a:t>
+                        <a:t>3.881</a:t>
                       </a:r>
                     </a:p>
                   </a:txBody>
@@ -7703,7 +7801,7 @@
                         </a:defRPr>
                       </a:pPr>
                       <a:r>
-                        <a:t>-0.540</a:t>
+                        <a:t>-0.637</a:t>
                       </a:r>
                     </a:p>
                   </a:txBody>
@@ -7723,7 +7821,7 @@
                         </a:defRPr>
                       </a:pPr>
                       <a:r>
-                        <a:t>0.224</a:t>
+                        <a:t>0.128</a:t>
                       </a:r>
                     </a:p>
                   </a:txBody>
@@ -7743,6 +7841,128 @@
                         </a:defRPr>
                       </a:pPr>
                       <a:r>
+                        <a:t>39.0%</a:t>
+                      </a:r>
+                    </a:p>
+                  </a:txBody>
+                  <a:tcPr marL="36576" marR="36576"/>
+                </a:tc>
+              </a:tr>
+              <a:tr h="470262">
+                <a:tc>
+                  <a:txBody>
+                    <a:bodyPr/>
+                    <a:lstStyle/>
+                    <a:p>
+                      <a:pPr algn="l">
+                        <a:defRPr sz="1100" b="0">
+                          <a:solidFill>
+                            <a:srgbClr val="0F172A"/>
+                          </a:solidFill>
+                          <a:latin typeface="Microsoft YaHei"/>
+                        </a:defRPr>
+                      </a:pPr>
+                      <a:r>
+                        <a:t>LLM trip suppression</a:t>
+                      </a:r>
+                    </a:p>
+                  </a:txBody>
+                  <a:tcPr marL="36576" marR="36576"/>
+                </a:tc>
+                <a:tc>
+                  <a:txBody>
+                    <a:bodyPr/>
+                    <a:lstStyle/>
+                    <a:p>
+                      <a:pPr algn="ctr">
+                        <a:defRPr sz="1100" b="0">
+                          <a:solidFill>
+                            <a:srgbClr val="0F172A"/>
+                          </a:solidFill>
+                          <a:latin typeface="Microsoft YaHei"/>
+                        </a:defRPr>
+                      </a:pPr>
+                      <a:r>
+                        <a:t>2.482</a:t>
+                      </a:r>
+                    </a:p>
+                  </a:txBody>
+                  <a:tcPr marL="36576" marR="36576"/>
+                </a:tc>
+                <a:tc>
+                  <a:txBody>
+                    <a:bodyPr/>
+                    <a:lstStyle/>
+                    <a:p>
+                      <a:pPr algn="ctr">
+                        <a:defRPr sz="1100" b="0">
+                          <a:solidFill>
+                            <a:srgbClr val="0F172A"/>
+                          </a:solidFill>
+                          <a:latin typeface="Microsoft YaHei"/>
+                        </a:defRPr>
+                      </a:pPr>
+                      <a:r>
+                        <a:t>3.660</a:t>
+                      </a:r>
+                    </a:p>
+                  </a:txBody>
+                  <a:tcPr marL="36576" marR="36576"/>
+                </a:tc>
+                <a:tc>
+                  <a:txBody>
+                    <a:bodyPr/>
+                    <a:lstStyle/>
+                    <a:p>
+                      <a:pPr algn="ctr">
+                        <a:defRPr sz="1100" b="0">
+                          <a:solidFill>
+                            <a:srgbClr val="0F172A"/>
+                          </a:solidFill>
+                          <a:latin typeface="Microsoft YaHei"/>
+                        </a:defRPr>
+                      </a:pPr>
+                      <a:r>
+                        <a:t>-0.540</a:t>
+                      </a:r>
+                    </a:p>
+                  </a:txBody>
+                  <a:tcPr marL="36576" marR="36576"/>
+                </a:tc>
+                <a:tc>
+                  <a:txBody>
+                    <a:bodyPr/>
+                    <a:lstStyle/>
+                    <a:p>
+                      <a:pPr algn="ctr">
+                        <a:defRPr sz="1100" b="0">
+                          <a:solidFill>
+                            <a:srgbClr val="0F172A"/>
+                          </a:solidFill>
+                          <a:latin typeface="Microsoft YaHei"/>
+                        </a:defRPr>
+                      </a:pPr>
+                      <a:r>
+                        <a:t>0.224</a:t>
+                      </a:r>
+                    </a:p>
+                  </a:txBody>
+                  <a:tcPr marL="36576" marR="36576"/>
+                </a:tc>
+                <a:tc>
+                  <a:txBody>
+                    <a:bodyPr/>
+                    <a:lstStyle/>
+                    <a:p>
+                      <a:pPr algn="ctr">
+                        <a:defRPr sz="1100" b="0">
+                          <a:solidFill>
+                            <a:srgbClr val="0F172A"/>
+                          </a:solidFill>
+                          <a:latin typeface="Microsoft YaHei"/>
+                        </a:defRPr>
+                      </a:pPr>
+                      <a:r>
                         <a:t>42.8%</a:t>
                       </a:r>
                     </a:p>
@@ -7750,7 +7970,7 @@
                   <a:tcPr marL="36576" marR="36576"/>
                 </a:tc>
               </a:tr>
-              <a:tr h="548640">
+              <a:tr h="470268">
                 <a:tc>
                   <a:txBody>
                     <a:bodyPr/>
@@ -7911,6 +8131,22 @@
             </a:pPr>
             <a:r>
               <a:t>Primary no-label gated rule: MAE 2.502, bias -0.023.</a:t>
+            </a:r>
+          </a:p>
+          <a:p>
+            <a:pPr>
+              <a:spcAft>
+                <a:spcPts val="800"/>
+              </a:spcAft>
+              <a:defRPr sz="1800" b="0">
+                <a:solidFill>
+                  <a:srgbClr val="0F172A"/>
+                </a:solidFill>
+                <a:latin typeface="Microsoft YaHei"/>
+              </a:defRPr>
+            </a:pPr>
+            <a:r>
+              <a:t>LLM-only pressure: MAE 2.718; hybrid keeps household-level baseline.</a:t>
             </a:r>
           </a:p>
           <a:p>

</xml_diff>

<commit_message>
docs(presentation): clarify hybrid adapter comparison
</commit_message>
<xml_diff>
--- a/outputs/final_project/NHTS_LLM_Event_Adaptation_Optimized_Presentation.pptx
+++ b/outputs/final_project/NHTS_LLM_Event_Adaptation_Optimized_Presentation.pptx
@@ -4892,7 +4892,7 @@
               </a:defRPr>
             </a:pPr>
             <a:r>
-              <a:t>Do not claim the best-MAE alpha was selected without looking at 2022 evaluation; treat it as sensitivity.</a:t>
+              <a:t>Keep parameter-sweep sensitivity rows in appendix/internal analysis, not in the main comparison.</a:t>
             </a:r>
           </a:p>
           <a:p>
@@ -6378,7 +6378,7 @@
                 <a:gridCol w="2766060"/>
                 <a:gridCol w="2766060"/>
               </a:tblGrid>
-              <a:tr h="485775">
+              <a:tr h="555171">
                 <a:tc>
                   <a:txBody>
                     <a:bodyPr/>
@@ -6476,7 +6476,7 @@
                   </a:tcPr>
                 </a:tc>
               </a:tr>
-              <a:tr h="485775">
+              <a:tr h="555171">
                 <a:tc>
                   <a:txBody>
                     <a:bodyPr/>
@@ -6558,7 +6558,7 @@
                   <a:tcPr marL="36576" marR="36576"/>
                 </a:tc>
               </a:tr>
-              <a:tr h="485775">
+              <a:tr h="555171">
                 <a:tc>
                   <a:txBody>
                     <a:bodyPr/>
@@ -6640,7 +6640,7 @@
                   <a:tcPr marL="36576" marR="36576"/>
                 </a:tc>
               </a:tr>
-              <a:tr h="485775">
+              <a:tr h="555171">
                 <a:tc>
                   <a:txBody>
                     <a:bodyPr/>
@@ -6722,7 +6722,7 @@
                   <a:tcPr marL="36576" marR="36576"/>
                 </a:tc>
               </a:tr>
-              <a:tr h="485775">
+              <a:tr h="555171">
                 <a:tc>
                   <a:txBody>
                     <a:bodyPr/>
@@ -6804,7 +6804,7 @@
                   <a:tcPr marL="36576" marR="36576"/>
                 </a:tc>
               </a:tr>
-              <a:tr h="485775">
+              <a:tr h="555171">
                 <a:tc>
                   <a:txBody>
                     <a:bodyPr/>
@@ -6886,89 +6886,7 @@
                   <a:tcPr marL="36576" marR="36576"/>
                 </a:tc>
               </a:tr>
-              <a:tr h="485775">
-                <a:tc>
-                  <a:txBody>
-                    <a:bodyPr/>
-                    <a:lstStyle/>
-                    <a:p>
-                      <a:pPr algn="l">
-                        <a:defRPr sz="1000" b="0">
-                          <a:solidFill>
-                            <a:srgbClr val="0F172A"/>
-                          </a:solidFill>
-                          <a:latin typeface="Microsoft YaHei"/>
-                        </a:defRPr>
-                      </a:pPr>
-                      <a:r>
-                        <a:t>LLM trip suppression</a:t>
-                      </a:r>
-                    </a:p>
-                  </a:txBody>
-                  <a:tcPr marL="36576" marR="36576"/>
-                </a:tc>
-                <a:tc>
-                  <a:txBody>
-                    <a:bodyPr/>
-                    <a:lstStyle/>
-                    <a:p>
-                      <a:pPr algn="ctr">
-                        <a:defRPr sz="1000" b="0">
-                          <a:solidFill>
-                            <a:srgbClr val="0F172A"/>
-                          </a:solidFill>
-                          <a:latin typeface="Microsoft YaHei"/>
-                        </a:defRPr>
-                      </a:pPr>
-                      <a:r>
-                        <a:t>No</a:t>
-                      </a:r>
-                    </a:p>
-                  </a:txBody>
-                  <a:tcPr marL="36576" marR="36576"/>
-                </a:tc>
-                <a:tc>
-                  <a:txBody>
-                    <a:bodyPr/>
-                    <a:lstStyle/>
-                    <a:p>
-                      <a:pPr algn="ctr">
-                        <a:defRPr sz="1000" b="0">
-                          <a:solidFill>
-                            <a:srgbClr val="0F172A"/>
-                          </a:solidFill>
-                          <a:latin typeface="Microsoft YaHei"/>
-                        </a:defRPr>
-                      </a:pPr>
-                      <a:r>
-                        <a:t>Cohort-specific</a:t>
-                      </a:r>
-                    </a:p>
-                  </a:txBody>
-                  <a:tcPr marL="36576" marR="36576"/>
-                </a:tc>
-                <a:tc>
-                  <a:txBody>
-                    <a:bodyPr/>
-                    <a:lstStyle/>
-                    <a:p>
-                      <a:pPr algn="ctr">
-                        <a:defRPr sz="1000" b="0">
-                          <a:solidFill>
-                            <a:srgbClr val="0F172A"/>
-                          </a:solidFill>
-                          <a:latin typeface="Microsoft YaHei"/>
-                        </a:defRPr>
-                      </a:pPr>
-                      <a:r>
-                        <a:t>Best-MAE sensitivity</a:t>
-                      </a:r>
-                    </a:p>
-                  </a:txBody>
-                  <a:tcPr marL="36576" marR="36576"/>
-                </a:tc>
-              </a:tr>
-              <a:tr h="485775">
+              <a:tr h="555174">
                 <a:tc>
                   <a:txBody>
                     <a:bodyPr/>
@@ -7497,7 +7415,7 @@
                         </a:defRPr>
                       </a:pPr>
                       <a:r>
-                        <a:t>Global event prior</a:t>
+                        <a:t>Historical trend shift</a:t>
                       </a:r>
                     </a:p>
                   </a:txBody>
@@ -7517,7 +7435,7 @@
                         </a:defRPr>
                       </a:pPr>
                       <a:r>
-                        <a:t>2.522</a:t>
+                        <a:t>4.150</a:t>
                       </a:r>
                     </a:p>
                   </a:txBody>
@@ -7537,7 +7455,7 @@
                         </a:defRPr>
                       </a:pPr>
                       <a:r>
-                        <a:t>3.743</a:t>
+                        <a:t>5.146</a:t>
                       </a:r>
                     </a:p>
                   </a:txBody>
@@ -7557,7 +7475,7 @@
                         </a:defRPr>
                       </a:pPr>
                       <a:r>
-                        <a:t>-0.748</a:t>
+                        <a:t>3.348</a:t>
                       </a:r>
                     </a:p>
                   </a:txBody>
@@ -7577,7 +7495,7 @@
                         </a:defRPr>
                       </a:pPr>
                       <a:r>
-                        <a:t>0.189</a:t>
+                        <a:t>-0.533</a:t>
                       </a:r>
                     </a:p>
                   </a:txBody>
@@ -7597,7 +7515,7 @@
                         </a:defRPr>
                       </a:pPr>
                       <a:r>
-                        <a:t>41.9%</a:t>
+                        <a:t>4.3%</a:t>
                       </a:r>
                     </a:p>
                   </a:txBody>
@@ -7741,7 +7659,7 @@
                         </a:defRPr>
                       </a:pPr>
                       <a:r>
-                        <a:t>Random prior control</a:t>
+                        <a:t>Global event prior</a:t>
                       </a:r>
                     </a:p>
                   </a:txBody>
@@ -7761,7 +7679,7 @@
                         </a:defRPr>
                       </a:pPr>
                       <a:r>
-                        <a:t>2.647</a:t>
+                        <a:t>2.522</a:t>
                       </a:r>
                     </a:p>
                   </a:txBody>
@@ -7781,7 +7699,7 @@
                         </a:defRPr>
                       </a:pPr>
                       <a:r>
-                        <a:t>3.881</a:t>
+                        <a:t>3.743</a:t>
                       </a:r>
                     </a:p>
                   </a:txBody>
@@ -7801,7 +7719,7 @@
                         </a:defRPr>
                       </a:pPr>
                       <a:r>
-                        <a:t>-0.637</a:t>
+                        <a:t>-0.748</a:t>
                       </a:r>
                     </a:p>
                   </a:txBody>
@@ -7821,7 +7739,7 @@
                         </a:defRPr>
                       </a:pPr>
                       <a:r>
-                        <a:t>0.128</a:t>
+                        <a:t>0.189</a:t>
                       </a:r>
                     </a:p>
                   </a:txBody>
@@ -7841,7 +7759,7 @@
                         </a:defRPr>
                       </a:pPr>
                       <a:r>
-                        <a:t>39.0%</a:t>
+                        <a:t>41.9%</a:t>
                       </a:r>
                     </a:p>
                   </a:txBody>
@@ -7863,7 +7781,7 @@
                         </a:defRPr>
                       </a:pPr>
                       <a:r>
-                        <a:t>LLM trip suppression</a:t>
+                        <a:t>Random prior control</a:t>
                       </a:r>
                     </a:p>
                   </a:txBody>
@@ -7883,7 +7801,7 @@
                         </a:defRPr>
                       </a:pPr>
                       <a:r>
-                        <a:t>2.482</a:t>
+                        <a:t>2.647</a:t>
                       </a:r>
                     </a:p>
                   </a:txBody>
@@ -7903,7 +7821,7 @@
                         </a:defRPr>
                       </a:pPr>
                       <a:r>
-                        <a:t>3.660</a:t>
+                        <a:t>3.881</a:t>
                       </a:r>
                     </a:p>
                   </a:txBody>
@@ -7923,7 +7841,7 @@
                         </a:defRPr>
                       </a:pPr>
                       <a:r>
-                        <a:t>-0.540</a:t>
+                        <a:t>-0.637</a:t>
                       </a:r>
                     </a:p>
                   </a:txBody>
@@ -7943,7 +7861,7 @@
                         </a:defRPr>
                       </a:pPr>
                       <a:r>
-                        <a:t>0.224</a:t>
+                        <a:t>0.128</a:t>
                       </a:r>
                     </a:p>
                   </a:txBody>
@@ -7963,7 +7881,7 @@
                         </a:defRPr>
                       </a:pPr>
                       <a:r>
-                        <a:t>42.8%</a:t>
+                        <a:t>39.0%</a:t>
                       </a:r>
                     </a:p>
                   </a:txBody>
@@ -8162,7 +8080,7 @@
               </a:defRPr>
             </a:pPr>
             <a:r>
-              <a:t>Best-MAE sensitivity row: MAE 2.482, a 42.8% reduction.</a:t>
+              <a:t>Parameter-sweep sensitivity rows are kept out of the public method comparison.</a:t>
             </a:r>
           </a:p>
         </p:txBody>
@@ -8476,7 +8394,7 @@
         <p:spPr>
           <a:xfrm>
             <a:off x="685800" y="1143000"/>
-            <a:ext cx="5486400" cy="2226029"/>
+            <a:ext cx="5486400" cy="2212963"/>
           </a:xfrm>
           <a:prstGeom prst="rect">
             <a:avLst/>

</xml_diff>

<commit_message>
feat(research): add rule-tree baselines and update deck
Add zero-shot LLM rule-tree, pseudo-label tree, small historical calibration, and irrelevant pseudo-event placebo baselines. Update reports, robustness audits, and the 23-slide template presentation with the full method comparison.
</commit_message>
<xml_diff>
--- a/outputs/final_project/NHTS_LLM_Event_Adaptation_Optimized_Presentation.pptx
+++ b/outputs/final_project/NHTS_LLM_Event_Adaptation_Optimized_Presentation.pptx
@@ -6364,7 +6364,7 @@
         </p:nvGraphicFramePr>
         <p:xfrm>
           <a:off x="594360" y="1188720"/>
-          <a:ext cx="11064240" cy="3886200"/>
+          <a:ext cx="11064240" cy="4251960"/>
         </p:xfrm>
         <a:graphic>
           <a:graphicData uri="http://schemas.openxmlformats.org/drawingml/2006/table">
@@ -6378,14 +6378,14 @@
                 <a:gridCol w="2766060"/>
                 <a:gridCol w="2766060"/>
               </a:tblGrid>
-              <a:tr h="555171">
+              <a:tr h="472440">
                 <a:tc>
                   <a:txBody>
                     <a:bodyPr/>
                     <a:lstStyle/>
                     <a:p>
                       <a:pPr algn="l">
-                        <a:defRPr sz="1000" b="1">
+                        <a:defRPr sz="800" b="1">
                           <a:solidFill>
                             <a:srgbClr val="0F172A"/>
                           </a:solidFill>
@@ -6409,7 +6409,7 @@
                     <a:lstStyle/>
                     <a:p>
                       <a:pPr algn="ctr">
-                        <a:defRPr sz="1000" b="1">
+                        <a:defRPr sz="800" b="1">
                           <a:solidFill>
                             <a:srgbClr val="0F172A"/>
                           </a:solidFill>
@@ -6433,7 +6433,7 @@
                     <a:lstStyle/>
                     <a:p>
                       <a:pPr algn="ctr">
-                        <a:defRPr sz="1000" b="1">
+                        <a:defRPr sz="800" b="1">
                           <a:solidFill>
                             <a:srgbClr val="0F172A"/>
                           </a:solidFill>
@@ -6457,7 +6457,7 @@
                     <a:lstStyle/>
                     <a:p>
                       <a:pPr algn="ctr">
-                        <a:defRPr sz="1000" b="1">
+                        <a:defRPr sz="800" b="1">
                           <a:solidFill>
                             <a:srgbClr val="0F172A"/>
                           </a:solidFill>
@@ -6476,14 +6476,14 @@
                   </a:tcPr>
                 </a:tc>
               </a:tr>
-              <a:tr h="555171">
+              <a:tr h="472440">
                 <a:tc>
                   <a:txBody>
                     <a:bodyPr/>
                     <a:lstStyle/>
                     <a:p>
                       <a:pPr algn="l">
-                        <a:defRPr sz="1000" b="0">
+                        <a:defRPr sz="800" b="0">
                           <a:solidFill>
                             <a:srgbClr val="0F172A"/>
                           </a:solidFill>
@@ -6503,7 +6503,7 @@
                     <a:lstStyle/>
                     <a:p>
                       <a:pPr algn="ctr">
-                        <a:defRPr sz="1000" b="0">
+                        <a:defRPr sz="800" b="0">
                           <a:solidFill>
                             <a:srgbClr val="0F172A"/>
                           </a:solidFill>
@@ -6523,7 +6523,7 @@
                     <a:lstStyle/>
                     <a:p>
                       <a:pPr algn="ctr">
-                        <a:defRPr sz="1000" b="0">
+                        <a:defRPr sz="800" b="0">
                           <a:solidFill>
                             <a:srgbClr val="0F172A"/>
                           </a:solidFill>
@@ -6543,7 +6543,7 @@
                     <a:lstStyle/>
                     <a:p>
                       <a:pPr algn="ctr">
-                        <a:defRPr sz="1000" b="0">
+                        <a:defRPr sz="800" b="0">
                           <a:solidFill>
                             <a:srgbClr val="0F172A"/>
                           </a:solidFill>
@@ -6558,14 +6558,14 @@
                   <a:tcPr marL="36576" marR="36576"/>
                 </a:tc>
               </a:tr>
-              <a:tr h="555171">
+              <a:tr h="472440">
                 <a:tc>
                   <a:txBody>
                     <a:bodyPr/>
                     <a:lstStyle/>
                     <a:p>
                       <a:pPr algn="l">
-                        <a:defRPr sz="1000" b="0">
+                        <a:defRPr sz="800" b="0">
                           <a:solidFill>
                             <a:srgbClr val="0F172A"/>
                           </a:solidFill>
@@ -6585,7 +6585,7 @@
                     <a:lstStyle/>
                     <a:p>
                       <a:pPr algn="ctr">
-                        <a:defRPr sz="1000" b="0">
+                        <a:defRPr sz="800" b="0">
                           <a:solidFill>
                             <a:srgbClr val="0F172A"/>
                           </a:solidFill>
@@ -6605,7 +6605,7 @@
                     <a:lstStyle/>
                     <a:p>
                       <a:pPr algn="ctr">
-                        <a:defRPr sz="1000" b="0">
+                        <a:defRPr sz="800" b="0">
                           <a:solidFill>
                             <a:srgbClr val="0F172A"/>
                           </a:solidFill>
@@ -6625,7 +6625,7 @@
                     <a:lstStyle/>
                     <a:p>
                       <a:pPr algn="ctr">
-                        <a:defRPr sz="1000" b="0">
+                        <a:defRPr sz="800" b="0">
                           <a:solidFill>
                             <a:srgbClr val="0F172A"/>
                           </a:solidFill>
@@ -6640,14 +6640,14 @@
                   <a:tcPr marL="36576" marR="36576"/>
                 </a:tc>
               </a:tr>
-              <a:tr h="555171">
+              <a:tr h="472440">
                 <a:tc>
                   <a:txBody>
                     <a:bodyPr/>
                     <a:lstStyle/>
                     <a:p>
                       <a:pPr algn="l">
-                        <a:defRPr sz="1000" b="0">
+                        <a:defRPr sz="800" b="0">
                           <a:solidFill>
                             <a:srgbClr val="0F172A"/>
                           </a:solidFill>
@@ -6667,7 +6667,7 @@
                     <a:lstStyle/>
                     <a:p>
                       <a:pPr algn="ctr">
-                        <a:defRPr sz="1000" b="0">
+                        <a:defRPr sz="800" b="0">
                           <a:solidFill>
                             <a:srgbClr val="0F172A"/>
                           </a:solidFill>
@@ -6687,7 +6687,7 @@
                     <a:lstStyle/>
                     <a:p>
                       <a:pPr algn="ctr">
-                        <a:defRPr sz="1000" b="0">
+                        <a:defRPr sz="800" b="0">
                           <a:solidFill>
                             <a:srgbClr val="0F172A"/>
                           </a:solidFill>
@@ -6707,7 +6707,7 @@
                     <a:lstStyle/>
                     <a:p>
                       <a:pPr algn="ctr">
-                        <a:defRPr sz="1000" b="0">
+                        <a:defRPr sz="800" b="0">
                           <a:solidFill>
                             <a:srgbClr val="0F172A"/>
                           </a:solidFill>
@@ -6722,14 +6722,178 @@
                   <a:tcPr marL="36576" marR="36576"/>
                 </a:tc>
               </a:tr>
-              <a:tr h="555171">
+              <a:tr h="472440">
                 <a:tc>
                   <a:txBody>
                     <a:bodyPr/>
                     <a:lstStyle/>
                     <a:p>
                       <a:pPr algn="l">
-                        <a:defRPr sz="1000" b="0">
+                        <a:defRPr sz="800" b="0">
+                          <a:solidFill>
+                            <a:srgbClr val="0F172A"/>
+                          </a:solidFill>
+                          <a:latin typeface="Microsoft YaHei"/>
+                        </a:defRPr>
+                      </a:pPr>
+                      <a:r>
+                        <a:t>Zero-shot rule tree</a:t>
+                      </a:r>
+                    </a:p>
+                  </a:txBody>
+                  <a:tcPr marL="36576" marR="36576"/>
+                </a:tc>
+                <a:tc>
+                  <a:txBody>
+                    <a:bodyPr/>
+                    <a:lstStyle/>
+                    <a:p>
+                      <a:pPr algn="ctr">
+                        <a:defRPr sz="800" b="0">
+                          <a:solidFill>
+                            <a:srgbClr val="0F172A"/>
+                          </a:solidFill>
+                          <a:latin typeface="Microsoft YaHei"/>
+                        </a:defRPr>
+                      </a:pPr>
+                      <a:r>
+                        <a:t>No</a:t>
+                      </a:r>
+                    </a:p>
+                  </a:txBody>
+                  <a:tcPr marL="36576" marR="36576"/>
+                </a:tc>
+                <a:tc>
+                  <a:txBody>
+                    <a:bodyPr/>
+                    <a:lstStyle/>
+                    <a:p>
+                      <a:pPr algn="ctr">
+                        <a:defRPr sz="800" b="0">
+                          <a:solidFill>
+                            <a:srgbClr val="0F172A"/>
+                          </a:solidFill>
+                          <a:latin typeface="Microsoft YaHei"/>
+                        </a:defRPr>
+                      </a:pPr>
+                      <a:r>
+                        <a:t>LLM-authored</a:t>
+                      </a:r>
+                    </a:p>
+                  </a:txBody>
+                  <a:tcPr marL="36576" marR="36576"/>
+                </a:tc>
+                <a:tc>
+                  <a:txBody>
+                    <a:bodyPr/>
+                    <a:lstStyle/>
+                    <a:p>
+                      <a:pPr algn="ctr">
+                        <a:defRPr sz="800" b="0">
+                          <a:solidFill>
+                            <a:srgbClr val="0F172A"/>
+                          </a:solidFill>
+                          <a:latin typeface="Microsoft YaHei"/>
+                        </a:defRPr>
+                      </a:pPr>
+                      <a:r>
+                        <a:t>Cold-start ablation</a:t>
+                      </a:r>
+                    </a:p>
+                  </a:txBody>
+                  <a:tcPr marL="36576" marR="36576"/>
+                </a:tc>
+              </a:tr>
+              <a:tr h="472440">
+                <a:tc>
+                  <a:txBody>
+                    <a:bodyPr/>
+                    <a:lstStyle/>
+                    <a:p>
+                      <a:pPr algn="l">
+                        <a:defRPr sz="800" b="0">
+                          <a:solidFill>
+                            <a:srgbClr val="0F172A"/>
+                          </a:solidFill>
+                          <a:latin typeface="Microsoft YaHei"/>
+                        </a:defRPr>
+                      </a:pPr>
+                      <a:r>
+                        <a:t>Rule + 500 history</a:t>
+                      </a:r>
+                    </a:p>
+                  </a:txBody>
+                  <a:tcPr marL="36576" marR="36576"/>
+                </a:tc>
+                <a:tc>
+                  <a:txBody>
+                    <a:bodyPr/>
+                    <a:lstStyle/>
+                    <a:p>
+                      <a:pPr algn="ctr">
+                        <a:defRPr sz="800" b="0">
+                          <a:solidFill>
+                            <a:srgbClr val="0F172A"/>
+                          </a:solidFill>
+                          <a:latin typeface="Microsoft YaHei"/>
+                        </a:defRPr>
+                      </a:pPr>
+                      <a:r>
+                        <a:t>No</a:t>
+                      </a:r>
+                    </a:p>
+                  </a:txBody>
+                  <a:tcPr marL="36576" marR="36576"/>
+                </a:tc>
+                <a:tc>
+                  <a:txBody>
+                    <a:bodyPr/>
+                    <a:lstStyle/>
+                    <a:p>
+                      <a:pPr algn="ctr">
+                        <a:defRPr sz="800" b="0">
+                          <a:solidFill>
+                            <a:srgbClr val="0F172A"/>
+                          </a:solidFill>
+                          <a:latin typeface="Microsoft YaHei"/>
+                        </a:defRPr>
+                      </a:pPr>
+                      <a:r>
+                        <a:t>LLM rules + data</a:t>
+                      </a:r>
+                    </a:p>
+                  </a:txBody>
+                  <a:tcPr marL="36576" marR="36576"/>
+                </a:tc>
+                <a:tc>
+                  <a:txBody>
+                    <a:bodyPr/>
+                    <a:lstStyle/>
+                    <a:p>
+                      <a:pPr algn="ctr">
+                        <a:defRPr sz="800" b="0">
+                          <a:solidFill>
+                            <a:srgbClr val="0F172A"/>
+                          </a:solidFill>
+                          <a:latin typeface="Microsoft YaHei"/>
+                        </a:defRPr>
+                      </a:pPr>
+                      <a:r>
+                        <a:t>Small-data bridge</a:t>
+                      </a:r>
+                    </a:p>
+                  </a:txBody>
+                  <a:tcPr marL="36576" marR="36576"/>
+                </a:tc>
+              </a:tr>
+              <a:tr h="472440">
+                <a:tc>
+                  <a:txBody>
+                    <a:bodyPr/>
+                    <a:lstStyle/>
+                    <a:p>
+                      <a:pPr algn="l">
+                        <a:defRPr sz="800" b="0">
                           <a:solidFill>
                             <a:srgbClr val="0F172A"/>
                           </a:solidFill>
@@ -6749,7 +6913,7 @@
                     <a:lstStyle/>
                     <a:p>
                       <a:pPr algn="ctr">
-                        <a:defRPr sz="1000" b="0">
+                        <a:defRPr sz="800" b="0">
                           <a:solidFill>
                             <a:srgbClr val="0F172A"/>
                           </a:solidFill>
@@ -6769,7 +6933,7 @@
                     <a:lstStyle/>
                     <a:p>
                       <a:pPr algn="ctr">
-                        <a:defRPr sz="1000" b="0">
+                        <a:defRPr sz="800" b="0">
                           <a:solidFill>
                             <a:srgbClr val="0F172A"/>
                           </a:solidFill>
@@ -6789,7 +6953,7 @@
                     <a:lstStyle/>
                     <a:p>
                       <a:pPr algn="ctr">
-                        <a:defRPr sz="1000" b="0">
+                        <a:defRPr sz="800" b="0">
                           <a:solidFill>
                             <a:srgbClr val="0F172A"/>
                           </a:solidFill>
@@ -6804,14 +6968,14 @@
                   <a:tcPr marL="36576" marR="36576"/>
                 </a:tc>
               </a:tr>
-              <a:tr h="555171">
+              <a:tr h="472440">
                 <a:tc>
                   <a:txBody>
                     <a:bodyPr/>
                     <a:lstStyle/>
                     <a:p>
                       <a:pPr algn="l">
-                        <a:defRPr sz="1000" b="0">
+                        <a:defRPr sz="800" b="0">
                           <a:solidFill>
                             <a:srgbClr val="0F172A"/>
                           </a:solidFill>
@@ -6831,7 +6995,7 @@
                     <a:lstStyle/>
                     <a:p>
                       <a:pPr algn="ctr">
-                        <a:defRPr sz="1000" b="0">
+                        <a:defRPr sz="800" b="0">
                           <a:solidFill>
                             <a:srgbClr val="0F172A"/>
                           </a:solidFill>
@@ -6851,7 +7015,7 @@
                     <a:lstStyle/>
                     <a:p>
                       <a:pPr algn="ctr">
-                        <a:defRPr sz="1000" b="0">
+                        <a:defRPr sz="800" b="0">
                           <a:solidFill>
                             <a:srgbClr val="0F172A"/>
                           </a:solidFill>
@@ -6871,7 +7035,7 @@
                     <a:lstStyle/>
                     <a:p>
                       <a:pPr algn="ctr">
-                        <a:defRPr sz="1000" b="0">
+                        <a:defRPr sz="800" b="0">
                           <a:solidFill>
                             <a:srgbClr val="0F172A"/>
                           </a:solidFill>
@@ -6886,14 +7050,14 @@
                   <a:tcPr marL="36576" marR="36576"/>
                 </a:tc>
               </a:tr>
-              <a:tr h="555174">
+              <a:tr h="472440">
                 <a:tc>
                   <a:txBody>
                     <a:bodyPr/>
                     <a:lstStyle/>
                     <a:p>
                       <a:pPr algn="l">
-                        <a:defRPr sz="1000" b="0">
+                        <a:defRPr sz="800" b="0">
                           <a:solidFill>
                             <a:srgbClr val="0F172A"/>
                           </a:solidFill>
@@ -6913,7 +7077,7 @@
                     <a:lstStyle/>
                     <a:p>
                       <a:pPr algn="ctr">
-                        <a:defRPr sz="1000" b="0">
+                        <a:defRPr sz="800" b="0">
                           <a:solidFill>
                             <a:srgbClr val="0F172A"/>
                           </a:solidFill>
@@ -6933,7 +7097,7 @@
                     <a:lstStyle/>
                     <a:p>
                       <a:pPr algn="ctr">
-                        <a:defRPr sz="1000" b="0">
+                        <a:defRPr sz="800" b="0">
                           <a:solidFill>
                             <a:srgbClr val="0F172A"/>
                           </a:solidFill>
@@ -6953,7 +7117,7 @@
                     <a:lstStyle/>
                     <a:p>
                       <a:pPr algn="ctr">
-                        <a:defRPr sz="1000" b="0">
+                        <a:defRPr sz="800" b="0">
                           <a:solidFill>
                             <a:srgbClr val="0F172A"/>
                           </a:solidFill>
@@ -7132,7 +7296,7 @@
                 <a:gridCol w="1844040"/>
                 <a:gridCol w="1844040"/>
               </a:tblGrid>
-              <a:tr h="470262">
+              <a:tr h="329184">
                 <a:tc>
                   <a:txBody>
                     <a:bodyPr/>
@@ -7278,7 +7442,7 @@
                   </a:tcPr>
                 </a:tc>
               </a:tr>
-              <a:tr h="470262">
+              <a:tr h="329184">
                 <a:tc>
                   <a:txBody>
                     <a:bodyPr/>
@@ -7400,7 +7564,7 @@
                   <a:tcPr marL="36576" marR="36576"/>
                 </a:tc>
               </a:tr>
-              <a:tr h="470262">
+              <a:tr h="329184">
                 <a:tc>
                   <a:txBody>
                     <a:bodyPr/>
@@ -7522,7 +7686,7 @@
                   <a:tcPr marL="36576" marR="36576"/>
                 </a:tc>
               </a:tr>
-              <a:tr h="470262">
+              <a:tr h="329184">
                 <a:tc>
                   <a:txBody>
                     <a:bodyPr/>
@@ -7644,7 +7808,7 @@
                   <a:tcPr marL="36576" marR="36576"/>
                 </a:tc>
               </a:tr>
-              <a:tr h="470262">
+              <a:tr h="329184">
                 <a:tc>
                   <a:txBody>
                     <a:bodyPr/>
@@ -7659,7 +7823,7 @@
                         </a:defRPr>
                       </a:pPr>
                       <a:r>
-                        <a:t>Global event prior</a:t>
+                        <a:t>Zero-shot LLM rule tree</a:t>
                       </a:r>
                     </a:p>
                   </a:txBody>
@@ -7679,7 +7843,7 @@
                         </a:defRPr>
                       </a:pPr>
                       <a:r>
-                        <a:t>2.522</a:t>
+                        <a:t>2.602</a:t>
                       </a:r>
                     </a:p>
                   </a:txBody>
@@ -7699,7 +7863,7 @@
                         </a:defRPr>
                       </a:pPr>
                       <a:r>
-                        <a:t>3.743</a:t>
+                        <a:t>3.830</a:t>
                       </a:r>
                     </a:p>
                   </a:txBody>
@@ -7719,7 +7883,7 @@
                         </a:defRPr>
                       </a:pPr>
                       <a:r>
-                        <a:t>-0.748</a:t>
+                        <a:t>-0.407</a:t>
                       </a:r>
                     </a:p>
                   </a:txBody>
@@ -7739,7 +7903,7 @@
                         </a:defRPr>
                       </a:pPr>
                       <a:r>
-                        <a:t>0.189</a:t>
+                        <a:t>0.151</a:t>
                       </a:r>
                     </a:p>
                   </a:txBody>
@@ -7759,14 +7923,14 @@
                         </a:defRPr>
                       </a:pPr>
                       <a:r>
-                        <a:t>41.9%</a:t>
+                        <a:t>40.0%</a:t>
                       </a:r>
                     </a:p>
                   </a:txBody>
                   <a:tcPr marL="36576" marR="36576"/>
                 </a:tc>
               </a:tr>
-              <a:tr h="470262">
+              <a:tr h="329184">
                 <a:tc>
                   <a:txBody>
                     <a:bodyPr/>
@@ -7781,6 +7945,372 @@
                         </a:defRPr>
                       </a:pPr>
                       <a:r>
+                        <a:t>Zero-shot pseudo-label tree</a:t>
+                      </a:r>
+                    </a:p>
+                  </a:txBody>
+                  <a:tcPr marL="36576" marR="36576"/>
+                </a:tc>
+                <a:tc>
+                  <a:txBody>
+                    <a:bodyPr/>
+                    <a:lstStyle/>
+                    <a:p>
+                      <a:pPr algn="ctr">
+                        <a:defRPr sz="1100" b="0">
+                          <a:solidFill>
+                            <a:srgbClr val="0F172A"/>
+                          </a:solidFill>
+                          <a:latin typeface="Microsoft YaHei"/>
+                        </a:defRPr>
+                      </a:pPr>
+                      <a:r>
+                        <a:t>2.604</a:t>
+                      </a:r>
+                    </a:p>
+                  </a:txBody>
+                  <a:tcPr marL="36576" marR="36576"/>
+                </a:tc>
+                <a:tc>
+                  <a:txBody>
+                    <a:bodyPr/>
+                    <a:lstStyle/>
+                    <a:p>
+                      <a:pPr algn="ctr">
+                        <a:defRPr sz="1100" b="0">
+                          <a:solidFill>
+                            <a:srgbClr val="0F172A"/>
+                          </a:solidFill>
+                          <a:latin typeface="Microsoft YaHei"/>
+                        </a:defRPr>
+                      </a:pPr>
+                      <a:r>
+                        <a:t>3.837</a:t>
+                      </a:r>
+                    </a:p>
+                  </a:txBody>
+                  <a:tcPr marL="36576" marR="36576"/>
+                </a:tc>
+                <a:tc>
+                  <a:txBody>
+                    <a:bodyPr/>
+                    <a:lstStyle/>
+                    <a:p>
+                      <a:pPr algn="ctr">
+                        <a:defRPr sz="1100" b="0">
+                          <a:solidFill>
+                            <a:srgbClr val="0F172A"/>
+                          </a:solidFill>
+                          <a:latin typeface="Microsoft YaHei"/>
+                        </a:defRPr>
+                      </a:pPr>
+                      <a:r>
+                        <a:t>-0.407</a:t>
+                      </a:r>
+                    </a:p>
+                  </a:txBody>
+                  <a:tcPr marL="36576" marR="36576"/>
+                </a:tc>
+                <a:tc>
+                  <a:txBody>
+                    <a:bodyPr/>
+                    <a:lstStyle/>
+                    <a:p>
+                      <a:pPr algn="ctr">
+                        <a:defRPr sz="1100" b="0">
+                          <a:solidFill>
+                            <a:srgbClr val="0F172A"/>
+                          </a:solidFill>
+                          <a:latin typeface="Microsoft YaHei"/>
+                        </a:defRPr>
+                      </a:pPr>
+                      <a:r>
+                        <a:t>0.148</a:t>
+                      </a:r>
+                    </a:p>
+                  </a:txBody>
+                  <a:tcPr marL="36576" marR="36576"/>
+                </a:tc>
+                <a:tc>
+                  <a:txBody>
+                    <a:bodyPr/>
+                    <a:lstStyle/>
+                    <a:p>
+                      <a:pPr algn="ctr">
+                        <a:defRPr sz="1100" b="0">
+                          <a:solidFill>
+                            <a:srgbClr val="0F172A"/>
+                          </a:solidFill>
+                          <a:latin typeface="Microsoft YaHei"/>
+                        </a:defRPr>
+                      </a:pPr>
+                      <a:r>
+                        <a:t>40.0%</a:t>
+                      </a:r>
+                    </a:p>
+                  </a:txBody>
+                  <a:tcPr marL="36576" marR="36576"/>
+                </a:tc>
+              </a:tr>
+              <a:tr h="329184">
+                <a:tc>
+                  <a:txBody>
+                    <a:bodyPr/>
+                    <a:lstStyle/>
+                    <a:p>
+                      <a:pPr algn="l">
+                        <a:defRPr sz="1100" b="0">
+                          <a:solidFill>
+                            <a:srgbClr val="0F172A"/>
+                          </a:solidFill>
+                          <a:latin typeface="Microsoft YaHei"/>
+                        </a:defRPr>
+                      </a:pPr>
+                      <a:r>
+                        <a:t>LLM rule + 500-history calibration</a:t>
+                      </a:r>
+                    </a:p>
+                  </a:txBody>
+                  <a:tcPr marL="36576" marR="36576"/>
+                </a:tc>
+                <a:tc>
+                  <a:txBody>
+                    <a:bodyPr/>
+                    <a:lstStyle/>
+                    <a:p>
+                      <a:pPr algn="ctr">
+                        <a:defRPr sz="1100" b="0">
+                          <a:solidFill>
+                            <a:srgbClr val="0F172A"/>
+                          </a:solidFill>
+                          <a:latin typeface="Microsoft YaHei"/>
+                        </a:defRPr>
+                      </a:pPr>
+                      <a:r>
+                        <a:t>2.772</a:t>
+                      </a:r>
+                    </a:p>
+                  </a:txBody>
+                  <a:tcPr marL="36576" marR="36576"/>
+                </a:tc>
+                <a:tc>
+                  <a:txBody>
+                    <a:bodyPr/>
+                    <a:lstStyle/>
+                    <a:p>
+                      <a:pPr algn="ctr">
+                        <a:defRPr sz="1100" b="0">
+                          <a:solidFill>
+                            <a:srgbClr val="0F172A"/>
+                          </a:solidFill>
+                          <a:latin typeface="Microsoft YaHei"/>
+                        </a:defRPr>
+                      </a:pPr>
+                      <a:r>
+                        <a:t>3.823</a:t>
+                      </a:r>
+                    </a:p>
+                  </a:txBody>
+                  <a:tcPr marL="36576" marR="36576"/>
+                </a:tc>
+                <a:tc>
+                  <a:txBody>
+                    <a:bodyPr/>
+                    <a:lstStyle/>
+                    <a:p>
+                      <a:pPr algn="ctr">
+                        <a:defRPr sz="1100" b="0">
+                          <a:solidFill>
+                            <a:srgbClr val="0F172A"/>
+                          </a:solidFill>
+                          <a:latin typeface="Microsoft YaHei"/>
+                        </a:defRPr>
+                      </a:pPr>
+                      <a:r>
+                        <a:t>0.463</a:t>
+                      </a:r>
+                    </a:p>
+                  </a:txBody>
+                  <a:tcPr marL="36576" marR="36576"/>
+                </a:tc>
+                <a:tc>
+                  <a:txBody>
+                    <a:bodyPr/>
+                    <a:lstStyle/>
+                    <a:p>
+                      <a:pPr algn="ctr">
+                        <a:defRPr sz="1100" b="0">
+                          <a:solidFill>
+                            <a:srgbClr val="0F172A"/>
+                          </a:solidFill>
+                          <a:latin typeface="Microsoft YaHei"/>
+                        </a:defRPr>
+                      </a:pPr>
+                      <a:r>
+                        <a:t>0.154</a:t>
+                      </a:r>
+                    </a:p>
+                  </a:txBody>
+                  <a:tcPr marL="36576" marR="36576"/>
+                </a:tc>
+                <a:tc>
+                  <a:txBody>
+                    <a:bodyPr/>
+                    <a:lstStyle/>
+                    <a:p>
+                      <a:pPr algn="ctr">
+                        <a:defRPr sz="1100" b="0">
+                          <a:solidFill>
+                            <a:srgbClr val="0F172A"/>
+                          </a:solidFill>
+                          <a:latin typeface="Microsoft YaHei"/>
+                        </a:defRPr>
+                      </a:pPr>
+                      <a:r>
+                        <a:t>36.1%</a:t>
+                      </a:r>
+                    </a:p>
+                  </a:txBody>
+                  <a:tcPr marL="36576" marR="36576"/>
+                </a:tc>
+              </a:tr>
+              <a:tr h="329184">
+                <a:tc>
+                  <a:txBody>
+                    <a:bodyPr/>
+                    <a:lstStyle/>
+                    <a:p>
+                      <a:pPr algn="l">
+                        <a:defRPr sz="1100" b="0">
+                          <a:solidFill>
+                            <a:srgbClr val="0F172A"/>
+                          </a:solidFill>
+                          <a:latin typeface="Microsoft YaHei"/>
+                        </a:defRPr>
+                      </a:pPr>
+                      <a:r>
+                        <a:t>Global event prior</a:t>
+                      </a:r>
+                    </a:p>
+                  </a:txBody>
+                  <a:tcPr marL="36576" marR="36576"/>
+                </a:tc>
+                <a:tc>
+                  <a:txBody>
+                    <a:bodyPr/>
+                    <a:lstStyle/>
+                    <a:p>
+                      <a:pPr algn="ctr">
+                        <a:defRPr sz="1100" b="0">
+                          <a:solidFill>
+                            <a:srgbClr val="0F172A"/>
+                          </a:solidFill>
+                          <a:latin typeface="Microsoft YaHei"/>
+                        </a:defRPr>
+                      </a:pPr>
+                      <a:r>
+                        <a:t>2.522</a:t>
+                      </a:r>
+                    </a:p>
+                  </a:txBody>
+                  <a:tcPr marL="36576" marR="36576"/>
+                </a:tc>
+                <a:tc>
+                  <a:txBody>
+                    <a:bodyPr/>
+                    <a:lstStyle/>
+                    <a:p>
+                      <a:pPr algn="ctr">
+                        <a:defRPr sz="1100" b="0">
+                          <a:solidFill>
+                            <a:srgbClr val="0F172A"/>
+                          </a:solidFill>
+                          <a:latin typeface="Microsoft YaHei"/>
+                        </a:defRPr>
+                      </a:pPr>
+                      <a:r>
+                        <a:t>3.743</a:t>
+                      </a:r>
+                    </a:p>
+                  </a:txBody>
+                  <a:tcPr marL="36576" marR="36576"/>
+                </a:tc>
+                <a:tc>
+                  <a:txBody>
+                    <a:bodyPr/>
+                    <a:lstStyle/>
+                    <a:p>
+                      <a:pPr algn="ctr">
+                        <a:defRPr sz="1100" b="0">
+                          <a:solidFill>
+                            <a:srgbClr val="0F172A"/>
+                          </a:solidFill>
+                          <a:latin typeface="Microsoft YaHei"/>
+                        </a:defRPr>
+                      </a:pPr>
+                      <a:r>
+                        <a:t>-0.748</a:t>
+                      </a:r>
+                    </a:p>
+                  </a:txBody>
+                  <a:tcPr marL="36576" marR="36576"/>
+                </a:tc>
+                <a:tc>
+                  <a:txBody>
+                    <a:bodyPr/>
+                    <a:lstStyle/>
+                    <a:p>
+                      <a:pPr algn="ctr">
+                        <a:defRPr sz="1100" b="0">
+                          <a:solidFill>
+                            <a:srgbClr val="0F172A"/>
+                          </a:solidFill>
+                          <a:latin typeface="Microsoft YaHei"/>
+                        </a:defRPr>
+                      </a:pPr>
+                      <a:r>
+                        <a:t>0.189</a:t>
+                      </a:r>
+                    </a:p>
+                  </a:txBody>
+                  <a:tcPr marL="36576" marR="36576"/>
+                </a:tc>
+                <a:tc>
+                  <a:txBody>
+                    <a:bodyPr/>
+                    <a:lstStyle/>
+                    <a:p>
+                      <a:pPr algn="ctr">
+                        <a:defRPr sz="1100" b="0">
+                          <a:solidFill>
+                            <a:srgbClr val="0F172A"/>
+                          </a:solidFill>
+                          <a:latin typeface="Microsoft YaHei"/>
+                        </a:defRPr>
+                      </a:pPr>
+                      <a:r>
+                        <a:t>41.9%</a:t>
+                      </a:r>
+                    </a:p>
+                  </a:txBody>
+                  <a:tcPr marL="36576" marR="36576"/>
+                </a:tc>
+              </a:tr>
+              <a:tr h="329184">
+                <a:tc>
+                  <a:txBody>
+                    <a:bodyPr/>
+                    <a:lstStyle/>
+                    <a:p>
+                      <a:pPr algn="l">
+                        <a:defRPr sz="1100" b="0">
+                          <a:solidFill>
+                            <a:srgbClr val="0F172A"/>
+                          </a:solidFill>
+                          <a:latin typeface="Microsoft YaHei"/>
+                        </a:defRPr>
+                      </a:pPr>
+                      <a:r>
                         <a:t>Random prior control</a:t>
                       </a:r>
                     </a:p>
@@ -7888,7 +8418,7 @@
                   <a:tcPr marL="36576" marR="36576"/>
                 </a:tc>
               </a:tr>
-              <a:tr h="470268">
+              <a:tr h="329184">
                 <a:tc>
                   <a:txBody>
                     <a:bodyPr/>

</xml_diff>

<commit_message>
refactor(baselines): reconcile zero-shot rule tree ablation
</commit_message>
<xml_diff>
--- a/outputs/final_project/NHTS_LLM_Event_Adaptation_Optimized_Presentation.pptx
+++ b/outputs/final_project/NHTS_LLM_Event_Adaptation_Optimized_Presentation.pptx
@@ -7843,7 +7843,7 @@
                         </a:defRPr>
                       </a:pPr>
                       <a:r>
-                        <a:t>2.602</a:t>
+                        <a:t>2.751</a:t>
                       </a:r>
                     </a:p>
                   </a:txBody>
@@ -7863,7 +7863,7 @@
                         </a:defRPr>
                       </a:pPr>
                       <a:r>
-                        <a:t>3.830</a:t>
+                        <a:t>3.783</a:t>
                       </a:r>
                     </a:p>
                   </a:txBody>
@@ -7883,7 +7883,7 @@
                         </a:defRPr>
                       </a:pPr>
                       <a:r>
-                        <a:t>-0.407</a:t>
+                        <a:t>0.500</a:t>
                       </a:r>
                     </a:p>
                   </a:txBody>
@@ -7903,7 +7903,7 @@
                         </a:defRPr>
                       </a:pPr>
                       <a:r>
-                        <a:t>0.151</a:t>
+                        <a:t>0.171</a:t>
                       </a:r>
                     </a:p>
                   </a:txBody>
@@ -7923,7 +7923,7 @@
                         </a:defRPr>
                       </a:pPr>
                       <a:r>
-                        <a:t>40.0%</a:t>
+                        <a:t>36.6%</a:t>
                       </a:r>
                     </a:p>
                   </a:txBody>
@@ -7965,7 +7965,7 @@
                         </a:defRPr>
                       </a:pPr>
                       <a:r>
-                        <a:t>2.604</a:t>
+                        <a:t>2.777</a:t>
                       </a:r>
                     </a:p>
                   </a:txBody>
@@ -7985,7 +7985,7 @@
                         </a:defRPr>
                       </a:pPr>
                       <a:r>
-                        <a:t>3.837</a:t>
+                        <a:t>3.820</a:t>
                       </a:r>
                     </a:p>
                   </a:txBody>
@@ -8005,7 +8005,7 @@
                         </a:defRPr>
                       </a:pPr>
                       <a:r>
-                        <a:t>-0.407</a:t>
+                        <a:t>0.500</a:t>
                       </a:r>
                     </a:p>
                   </a:txBody>
@@ -8025,7 +8025,7 @@
                         </a:defRPr>
                       </a:pPr>
                       <a:r>
-                        <a:t>0.148</a:t>
+                        <a:t>0.155</a:t>
                       </a:r>
                     </a:p>
                   </a:txBody>
@@ -8045,7 +8045,7 @@
                         </a:defRPr>
                       </a:pPr>
                       <a:r>
-                        <a:t>40.0%</a:t>
+                        <a:t>36.0%</a:t>
                       </a:r>
                     </a:p>
                   </a:txBody>

</xml_diff>

<commit_message>
feat(evaluation): harmonize mode choice and uncertainty pareto
Map year-specific NHTS TRPTRANS codes into comparable MODE_GROUP targets before building mode-choice datasets.

Add uncertainty-aware Pareto selection, refresh final reports, PPT assets, and readiness audits.
</commit_message>
<xml_diff>
--- a/outputs/final_project/NHTS_LLM_Event_Adaptation_Optimized_Presentation.pptx
+++ b/outputs/final_project/NHTS_LLM_Event_Adaptation_Optimized_Presentation.pptx
@@ -3825,7 +3825,7 @@
         <p:spPr>
           <a:xfrm>
             <a:off x="822960" y="1143000"/>
-            <a:ext cx="10561320" cy="4346185"/>
+            <a:ext cx="10561320" cy="4349556"/>
           </a:xfrm>
           <a:prstGeom prst="rect">
             <a:avLst/>
@@ -8766,7 +8766,7 @@
         <p:spPr>
           <a:xfrm>
             <a:off x="731520" y="1097280"/>
-            <a:ext cx="10881360" cy="5381492"/>
+            <a:ext cx="10881360" cy="5381542"/>
           </a:xfrm>
           <a:prstGeom prst="rect">
             <a:avLst/>
@@ -8924,7 +8924,7 @@
         <p:spPr>
           <a:xfrm>
             <a:off x="685800" y="1143000"/>
-            <a:ext cx="5486400" cy="2212963"/>
+            <a:ext cx="5486400" cy="2211554"/>
           </a:xfrm>
           <a:prstGeom prst="rect">
             <a:avLst/>
@@ -8948,7 +8948,7 @@
         <p:spPr>
           <a:xfrm>
             <a:off x="6309360" y="1143000"/>
-            <a:ext cx="5349240" cy="2618312"/>
+            <a:ext cx="5349240" cy="2614871"/>
           </a:xfrm>
           <a:prstGeom prst="rect">
             <a:avLst/>
@@ -8989,7 +8989,7 @@
               </a:defRPr>
             </a:pPr>
             <a:r>
-              <a:t>Gated MAE: 2.47 trips per household.</a:t>
+              <a:t>Gated MAE: 2.48 trips per household.</a:t>
             </a:r>
           </a:p>
           <a:p>
@@ -9005,7 +9005,7 @@
               </a:defRPr>
             </a:pPr>
             <a:r>
-              <a:t>Within 2 trips: 54.5%; within 3 trips: 71.2%.</a:t>
+              <a:t>Within 2 trips: 54.0%; within 3 trips: 71.1%.</a:t>
             </a:r>
           </a:p>
         </p:txBody>

</xml_diff>

<commit_message>
feat(mode-choice): add harmonized transfer baseline
Train 2017 harmonized MODE_GROUP XGBoost baselines and evaluate on 2022 without target-year training labels.

Report accuracy, balanced accuracy, macro F1, per-class metrics, confusion matrix, and audit gates for rare-mode limitations.
</commit_message>
<xml_diff>
--- a/outputs/final_project/NHTS_LLM_Event_Adaptation_Optimized_Presentation.pptx
+++ b/outputs/final_project/NHTS_LLM_Event_Adaptation_Optimized_Presentation.pptx
@@ -20,6 +20,7 @@
     <p:sldId id="268" r:id="rId19"/>
     <p:sldId id="269" r:id="rId20"/>
     <p:sldId id="270" r:id="rId21"/>
+    <p:sldId id="271" r:id="rId22"/>
   </p:sldIdLst>
   <p:sldSz cx="12191695" cy="6858000" type="screen4x3"/>
   <p:notesSz cx="6858000" cy="9144000"/>
@@ -3944,7 +3945,7 @@
               </a:defRPr>
             </a:pPr>
             <a:r>
-              <a:t>Metric guide</a:t>
+              <a:t>Trip-level mode-choice transfer</a:t>
             </a:r>
           </a:p>
         </p:txBody>
@@ -3980,7 +3981,7 @@
               </a:defRPr>
             </a:pPr>
             <a:r>
-              <a:t>How to read the numbers</a:t>
+              <a:t>Harmonized MODE_GROUP avoids raw TRPTRANS code mismatch</a:t>
             </a:r>
           </a:p>
         </p:txBody>
@@ -4030,8 +4031,8 @@
           <p:nvPr/>
         </p:nvGraphicFramePr>
         <p:xfrm>
-          <a:off x="685800" y="1234440"/>
-          <a:ext cx="10789920" cy="3108960"/>
+          <a:off x="685800" y="1143000"/>
+          <a:ext cx="5212080" cy="1234440"/>
         </p:xfrm>
         <a:graphic>
           <a:graphicData uri="http://schemas.openxmlformats.org/drawingml/2006/table">
@@ -4040,26 +4041,27 @@
                 <a:tableStyleId>{5C22544A-7EE6-4342-B048-85BDC9FD1C3A}</a:tableStyleId>
               </a:tblPr>
               <a:tblGrid>
-                <a:gridCol w="3596640"/>
-                <a:gridCol w="3596640"/>
-                <a:gridCol w="3596640"/>
+                <a:gridCol w="1303020"/>
+                <a:gridCol w="1303020"/>
+                <a:gridCol w="1303020"/>
+                <a:gridCol w="1303020"/>
               </a:tblGrid>
-              <a:tr h="518160">
+              <a:tr h="411480">
                 <a:tc>
                   <a:txBody>
                     <a:bodyPr/>
                     <a:lstStyle/>
                     <a:p>
                       <a:pPr algn="l">
-                        <a:defRPr sz="1200" b="1">
-                          <a:solidFill>
-                            <a:srgbClr val="0F172A"/>
-                          </a:solidFill>
-                          <a:latin typeface="Microsoft YaHei"/>
-                        </a:defRPr>
-                      </a:pPr>
-                      <a:r>
-                        <a:t>Metric</a:t>
+                        <a:defRPr sz="1100" b="1">
+                          <a:solidFill>
+                            <a:srgbClr val="0F172A"/>
+                          </a:solidFill>
+                          <a:latin typeface="Microsoft YaHei"/>
+                        </a:defRPr>
+                      </a:pPr>
+                      <a:r>
+                        <a:t>Model</a:t>
                       </a:r>
                     </a:p>
                   </a:txBody>
@@ -4075,15 +4077,15 @@
                     <a:lstStyle/>
                     <a:p>
                       <a:pPr algn="ctr">
-                        <a:defRPr sz="1200" b="1">
-                          <a:solidFill>
-                            <a:srgbClr val="0F172A"/>
-                          </a:solidFill>
-                          <a:latin typeface="Microsoft YaHei"/>
-                        </a:defRPr>
-                      </a:pPr>
-                      <a:r>
-                        <a:t>Task</a:t>
+                        <a:defRPr sz="1100" b="1">
+                          <a:solidFill>
+                            <a:srgbClr val="0F172A"/>
+                          </a:solidFill>
+                          <a:latin typeface="Microsoft YaHei"/>
+                        </a:defRPr>
+                      </a:pPr>
+                      <a:r>
+                        <a:t>Accuracy</a:t>
                       </a:r>
                     </a:p>
                   </a:txBody>
@@ -4099,15 +4101,15 @@
                     <a:lstStyle/>
                     <a:p>
                       <a:pPr algn="ctr">
-                        <a:defRPr sz="1200" b="1">
-                          <a:solidFill>
-                            <a:srgbClr val="0F172A"/>
-                          </a:solidFill>
-                          <a:latin typeface="Microsoft YaHei"/>
-                        </a:defRPr>
-                      </a:pPr>
-                      <a:r>
-                        <a:t>Meaning</a:t>
+                        <a:defRPr sz="1100" b="1">
+                          <a:solidFill>
+                            <a:srgbClr val="0F172A"/>
+                          </a:solidFill>
+                          <a:latin typeface="Microsoft YaHei"/>
+                        </a:defRPr>
+                      </a:pPr>
+                      <a:r>
+                        <a:t>Balanced acc.</a:t>
                       </a:r>
                     </a:p>
                   </a:txBody>
@@ -4117,311 +4119,189 @@
                     </a:solidFill>
                   </a:tcPr>
                 </a:tc>
+                <a:tc>
+                  <a:txBody>
+                    <a:bodyPr/>
+                    <a:lstStyle/>
+                    <a:p>
+                      <a:pPr algn="ctr">
+                        <a:defRPr sz="1100" b="1">
+                          <a:solidFill>
+                            <a:srgbClr val="0F172A"/>
+                          </a:solidFill>
+                          <a:latin typeface="Microsoft YaHei"/>
+                        </a:defRPr>
+                      </a:pPr>
+                      <a:r>
+                        <a:t>Macro F1</a:t>
+                      </a:r>
+                    </a:p>
+                  </a:txBody>
+                  <a:tcPr marL="36576" marR="36576">
+                    <a:solidFill>
+                      <a:srgbClr val="E2E8F0"/>
+                    </a:solidFill>
+                  </a:tcPr>
+                </a:tc>
               </a:tr>
-              <a:tr h="518160">
+              <a:tr h="411480">
                 <a:tc>
                   <a:txBody>
                     <a:bodyPr/>
                     <a:lstStyle/>
                     <a:p>
                       <a:pPr algn="l">
-                        <a:defRPr sz="1200" b="0">
-                          <a:solidFill>
-                            <a:srgbClr val="0F172A"/>
-                          </a:solidFill>
-                          <a:latin typeface="Microsoft YaHei"/>
-                        </a:defRPr>
-                      </a:pPr>
-                      <a:r>
-                        <a:t>Weighted MAE</a:t>
-                      </a:r>
-                    </a:p>
-                  </a:txBody>
-                  <a:tcPr marL="36576" marR="36576"/>
-                </a:tc>
-                <a:tc>
-                  <a:txBody>
-                    <a:bodyPr/>
-                    <a:lstStyle/>
-                    <a:p>
-                      <a:pPr algn="ctr">
-                        <a:defRPr sz="1200" b="0">
-                          <a:solidFill>
-                            <a:srgbClr val="0F172A"/>
-                          </a:solidFill>
-                          <a:latin typeface="Microsoft YaHei"/>
-                        </a:defRPr>
-                      </a:pPr>
-                      <a:r>
-                        <a:t>Trip count</a:t>
-                      </a:r>
-                    </a:p>
-                  </a:txBody>
-                  <a:tcPr marL="36576" marR="36576"/>
-                </a:tc>
-                <a:tc>
-                  <a:txBody>
-                    <a:bodyPr/>
-                    <a:lstStyle/>
-                    <a:p>
-                      <a:pPr algn="ctr">
-                        <a:defRPr sz="1200" b="0">
-                          <a:solidFill>
-                            <a:srgbClr val="0F172A"/>
-                          </a:solidFill>
-                          <a:latin typeface="Microsoft YaHei"/>
-                        </a:defRPr>
-                      </a:pPr>
-                      <a:r>
-                        <a:t>Average absolute trip-count error</a:t>
+                        <a:defRPr sz="1100" b="0">
+                          <a:solidFill>
+                            <a:srgbClr val="0F172A"/>
+                          </a:solidFill>
+                          <a:latin typeface="Microsoft YaHei"/>
+                        </a:defRPr>
+                      </a:pPr>
+                      <a:r>
+                        <a:t>XGBoost</a:t>
+                      </a:r>
+                    </a:p>
+                  </a:txBody>
+                  <a:tcPr marL="36576" marR="36576"/>
+                </a:tc>
+                <a:tc>
+                  <a:txBody>
+                    <a:bodyPr/>
+                    <a:lstStyle/>
+                    <a:p>
+                      <a:pPr algn="ctr">
+                        <a:defRPr sz="1100" b="0">
+                          <a:solidFill>
+                            <a:srgbClr val="0F172A"/>
+                          </a:solidFill>
+                          <a:latin typeface="Microsoft YaHei"/>
+                        </a:defRPr>
+                      </a:pPr>
+                      <a:r>
+                        <a:t>0.9373</a:t>
+                      </a:r>
+                    </a:p>
+                  </a:txBody>
+                  <a:tcPr marL="36576" marR="36576"/>
+                </a:tc>
+                <a:tc>
+                  <a:txBody>
+                    <a:bodyPr/>
+                    <a:lstStyle/>
+                    <a:p>
+                      <a:pPr algn="ctr">
+                        <a:defRPr sz="1100" b="0">
+                          <a:solidFill>
+                            <a:srgbClr val="0F172A"/>
+                          </a:solidFill>
+                          <a:latin typeface="Microsoft YaHei"/>
+                        </a:defRPr>
+                      </a:pPr>
+                      <a:r>
+                        <a:t>0.4309</a:t>
+                      </a:r>
+                    </a:p>
+                  </a:txBody>
+                  <a:tcPr marL="36576" marR="36576"/>
+                </a:tc>
+                <a:tc>
+                  <a:txBody>
+                    <a:bodyPr/>
+                    <a:lstStyle/>
+                    <a:p>
+                      <a:pPr algn="ctr">
+                        <a:defRPr sz="1100" b="0">
+                          <a:solidFill>
+                            <a:srgbClr val="0F172A"/>
+                          </a:solidFill>
+                          <a:latin typeface="Microsoft YaHei"/>
+                        </a:defRPr>
+                      </a:pPr>
+                      <a:r>
+                        <a:t>0.4658</a:t>
                       </a:r>
                     </a:p>
                   </a:txBody>
                   <a:tcPr marL="36576" marR="36576"/>
                 </a:tc>
               </a:tr>
-              <a:tr h="518160">
+              <a:tr h="411480">
                 <a:tc>
                   <a:txBody>
                     <a:bodyPr/>
                     <a:lstStyle/>
                     <a:p>
                       <a:pPr algn="l">
-                        <a:defRPr sz="1200" b="0">
-                          <a:solidFill>
-                            <a:srgbClr val="0F172A"/>
-                          </a:solidFill>
-                          <a:latin typeface="Microsoft YaHei"/>
-                        </a:defRPr>
-                      </a:pPr>
-                      <a:r>
-                        <a:t>Weighted Bias</a:t>
-                      </a:r>
-                    </a:p>
-                  </a:txBody>
-                  <a:tcPr marL="36576" marR="36576"/>
-                </a:tc>
-                <a:tc>
-                  <a:txBody>
-                    <a:bodyPr/>
-                    <a:lstStyle/>
-                    <a:p>
-                      <a:pPr algn="ctr">
-                        <a:defRPr sz="1200" b="0">
-                          <a:solidFill>
-                            <a:srgbClr val="0F172A"/>
-                          </a:solidFill>
-                          <a:latin typeface="Microsoft YaHei"/>
-                        </a:defRPr>
-                      </a:pPr>
-                      <a:r>
-                        <a:t>Trip count</a:t>
-                      </a:r>
-                    </a:p>
-                  </a:txBody>
-                  <a:tcPr marL="36576" marR="36576"/>
-                </a:tc>
-                <a:tc>
-                  <a:txBody>
-                    <a:bodyPr/>
-                    <a:lstStyle/>
-                    <a:p>
-                      <a:pPr algn="ctr">
-                        <a:defRPr sz="1200" b="0">
-                          <a:solidFill>
-                            <a:srgbClr val="0F172A"/>
-                          </a:solidFill>
-                          <a:latin typeface="Microsoft YaHei"/>
-                        </a:defRPr>
-                      </a:pPr>
-                      <a:r>
-                        <a:t>Systematic over/under prediction</a:t>
-                      </a:r>
-                    </a:p>
-                  </a:txBody>
-                  <a:tcPr marL="36576" marR="36576"/>
-                </a:tc>
-              </a:tr>
-              <a:tr h="518160">
-                <a:tc>
-                  <a:txBody>
-                    <a:bodyPr/>
-                    <a:lstStyle/>
-                    <a:p>
-                      <a:pPr algn="l">
-                        <a:defRPr sz="1200" b="0">
-                          <a:solidFill>
-                            <a:srgbClr val="0F172A"/>
-                          </a:solidFill>
-                          <a:latin typeface="Microsoft YaHei"/>
-                        </a:defRPr>
-                      </a:pPr>
-                      <a:r>
-                        <a:t>Within-k</a:t>
-                      </a:r>
-                    </a:p>
-                  </a:txBody>
-                  <a:tcPr marL="36576" marR="36576"/>
-                </a:tc>
-                <a:tc>
-                  <a:txBody>
-                    <a:bodyPr/>
-                    <a:lstStyle/>
-                    <a:p>
-                      <a:pPr algn="ctr">
-                        <a:defRPr sz="1200" b="0">
-                          <a:solidFill>
-                            <a:srgbClr val="0F172A"/>
-                          </a:solidFill>
-                          <a:latin typeface="Microsoft YaHei"/>
-                        </a:defRPr>
-                      </a:pPr>
-                      <a:r>
-                        <a:t>Trip count</a:t>
-                      </a:r>
-                    </a:p>
-                  </a:txBody>
-                  <a:tcPr marL="36576" marR="36576"/>
-                </a:tc>
-                <a:tc>
-                  <a:txBody>
-                    <a:bodyPr/>
-                    <a:lstStyle/>
-                    <a:p>
-                      <a:pPr algn="ctr">
-                        <a:defRPr sz="1200" b="0">
-                          <a:solidFill>
-                            <a:srgbClr val="0F172A"/>
-                          </a:solidFill>
-                          <a:latin typeface="Microsoft YaHei"/>
-                        </a:defRPr>
-                      </a:pPr>
-                      <a:r>
-                        <a:t>Households within k trips</a:t>
-                      </a:r>
-                    </a:p>
-                  </a:txBody>
-                  <a:tcPr marL="36576" marR="36576"/>
-                </a:tc>
-              </a:tr>
-              <a:tr h="518160">
-                <a:tc>
-                  <a:txBody>
-                    <a:bodyPr/>
-                    <a:lstStyle/>
-                    <a:p>
-                      <a:pPr algn="l">
-                        <a:defRPr sz="1200" b="0">
-                          <a:solidFill>
-                            <a:srgbClr val="0F172A"/>
-                          </a:solidFill>
-                          <a:latin typeface="Microsoft YaHei"/>
-                        </a:defRPr>
-                      </a:pPr>
-                      <a:r>
-                        <a:t>Weighted TV</a:t>
-                      </a:r>
-                    </a:p>
-                  </a:txBody>
-                  <a:tcPr marL="36576" marR="36576"/>
-                </a:tc>
-                <a:tc>
-                  <a:txBody>
-                    <a:bodyPr/>
-                    <a:lstStyle/>
-                    <a:p>
-                      <a:pPr algn="ctr">
-                        <a:defRPr sz="1200" b="0">
-                          <a:solidFill>
-                            <a:srgbClr val="0F172A"/>
-                          </a:solidFill>
-                          <a:latin typeface="Microsoft YaHei"/>
-                        </a:defRPr>
-                      </a:pPr>
-                      <a:r>
-                        <a:t>Mode composition</a:t>
-                      </a:r>
-                    </a:p>
-                  </a:txBody>
-                  <a:tcPr marL="36576" marR="36576"/>
-                </a:tc>
-                <a:tc>
-                  <a:txBody>
-                    <a:bodyPr/>
-                    <a:lstStyle/>
-                    <a:p>
-                      <a:pPr algn="ctr">
-                        <a:defRPr sz="1200" b="0">
-                          <a:solidFill>
-                            <a:srgbClr val="0F172A"/>
-                          </a:solidFill>
-                          <a:latin typeface="Microsoft YaHei"/>
-                        </a:defRPr>
-                      </a:pPr>
-                      <a:r>
-                        <a:t>Whole share-vector error</a:t>
-                      </a:r>
-                    </a:p>
-                  </a:txBody>
-                  <a:tcPr marL="36576" marR="36576"/>
-                </a:tc>
-              </a:tr>
-              <a:tr h="518160">
-                <a:tc>
-                  <a:txBody>
-                    <a:bodyPr/>
-                    <a:lstStyle/>
-                    <a:p>
-                      <a:pPr algn="l">
-                        <a:defRPr sz="1200" b="0">
-                          <a:solidFill>
-                            <a:srgbClr val="0F172A"/>
-                          </a:solidFill>
-                          <a:latin typeface="Microsoft YaHei"/>
-                        </a:defRPr>
-                      </a:pPr>
-                      <a:r>
-                        <a:t>Transit-share MAE</a:t>
-                      </a:r>
-                    </a:p>
-                  </a:txBody>
-                  <a:tcPr marL="36576" marR="36576"/>
-                </a:tc>
-                <a:tc>
-                  <a:txBody>
-                    <a:bodyPr/>
-                    <a:lstStyle/>
-                    <a:p>
-                      <a:pPr algn="ctr">
-                        <a:defRPr sz="1200" b="0">
-                          <a:solidFill>
-                            <a:srgbClr val="0F172A"/>
-                          </a:solidFill>
-                          <a:latin typeface="Microsoft YaHei"/>
-                        </a:defRPr>
-                      </a:pPr>
-                      <a:r>
-                        <a:t>Mode composition</a:t>
-                      </a:r>
-                    </a:p>
-                  </a:txBody>
-                  <a:tcPr marL="36576" marR="36576"/>
-                </a:tc>
-                <a:tc>
-                  <a:txBody>
-                    <a:bodyPr/>
-                    <a:lstStyle/>
-                    <a:p>
-                      <a:pPr algn="ctr">
-                        <a:defRPr sz="1200" b="0">
-                          <a:solidFill>
-                            <a:srgbClr val="0F172A"/>
-                          </a:solidFill>
-                          <a:latin typeface="Microsoft YaHei"/>
-                        </a:defRPr>
-                      </a:pPr>
-                      <a:r>
-                        <a:t>Public-transit share error</a:t>
+                        <a:defRPr sz="1100" b="0">
+                          <a:solidFill>
+                            <a:srgbClr val="0F172A"/>
+                          </a:solidFill>
+                          <a:latin typeface="Microsoft YaHei"/>
+                        </a:defRPr>
+                      </a:pPr>
+                      <a:r>
+                        <a:t>Class-balanced</a:t>
+                      </a:r>
+                    </a:p>
+                  </a:txBody>
+                  <a:tcPr marL="36576" marR="36576"/>
+                </a:tc>
+                <a:tc>
+                  <a:txBody>
+                    <a:bodyPr/>
+                    <a:lstStyle/>
+                    <a:p>
+                      <a:pPr algn="ctr">
+                        <a:defRPr sz="1100" b="0">
+                          <a:solidFill>
+                            <a:srgbClr val="0F172A"/>
+                          </a:solidFill>
+                          <a:latin typeface="Microsoft YaHei"/>
+                        </a:defRPr>
+                      </a:pPr>
+                      <a:r>
+                        <a:t>0.6758</a:t>
+                      </a:r>
+                    </a:p>
+                  </a:txBody>
+                  <a:tcPr marL="36576" marR="36576"/>
+                </a:tc>
+                <a:tc>
+                  <a:txBody>
+                    <a:bodyPr/>
+                    <a:lstStyle/>
+                    <a:p>
+                      <a:pPr algn="ctr">
+                        <a:defRPr sz="1100" b="0">
+                          <a:solidFill>
+                            <a:srgbClr val="0F172A"/>
+                          </a:solidFill>
+                          <a:latin typeface="Microsoft YaHei"/>
+                        </a:defRPr>
+                      </a:pPr>
+                      <a:r>
+                        <a:t>0.6167</a:t>
+                      </a:r>
+                    </a:p>
+                  </a:txBody>
+                  <a:tcPr marL="36576" marR="36576"/>
+                </a:tc>
+                <a:tc>
+                  <a:txBody>
+                    <a:bodyPr/>
+                    <a:lstStyle/>
+                    <a:p>
+                      <a:pPr algn="ctr">
+                        <a:defRPr sz="1100" b="0">
+                          <a:solidFill>
+                            <a:srgbClr val="0F172A"/>
+                          </a:solidFill>
+                          <a:latin typeface="Microsoft YaHei"/>
+                        </a:defRPr>
+                      </a:pPr>
+                      <a:r>
+                        <a:t>0.3553</a:t>
                       </a:r>
                     </a:p>
                   </a:txBody>
@@ -4440,8 +4320,8 @@
         </p:nvSpPr>
         <p:spPr>
           <a:xfrm>
-            <a:off x="914400" y="4846320"/>
-            <a:ext cx="10058400" cy="640080"/>
+            <a:off x="822960" y="2743200"/>
+            <a:ext cx="5074920" cy="2194560"/>
           </a:xfrm>
           <a:prstGeom prst="rect">
             <a:avLst/>
@@ -4458,7 +4338,7 @@
               <a:spcAft>
                 <a:spcPts val="800"/>
               </a:spcAft>
-              <a:defRPr sz="1800" b="0">
+              <a:defRPr sz="1600" b="0">
                 <a:solidFill>
                   <a:srgbClr val="0F172A"/>
                 </a:solidFill>
@@ -4466,11 +4346,67 @@
               </a:defRPr>
             </a:pPr>
             <a:r>
-              <a:t>Lower is better for errors; bias closer to zero is better; R2 and accuracy are higher-is-better.</a:t>
-            </a:r>
-          </a:p>
-        </p:txBody>
-      </p:sp>
+              <a:t>Train on 2017 labels; use 2022 labels only for final evaluation.</a:t>
+            </a:r>
+          </a:p>
+          <a:p>
+            <a:pPr>
+              <a:spcAft>
+                <a:spcPts val="800"/>
+              </a:spcAft>
+              <a:defRPr sz="1600" b="0">
+                <a:solidFill>
+                  <a:srgbClr val="0F172A"/>
+                </a:solidFill>
+                <a:latin typeface="Microsoft YaHei"/>
+              </a:defRPr>
+            </a:pPr>
+            <a:r>
+              <a:t>Accuracy is high because private vehicle dominates.</a:t>
+            </a:r>
+          </a:p>
+          <a:p>
+            <a:pPr>
+              <a:spcAft>
+                <a:spcPts val="800"/>
+              </a:spcAft>
+              <a:defRPr sz="1600" b="0">
+                <a:solidFill>
+                  <a:srgbClr val="0F172A"/>
+                </a:solidFill>
+                <a:latin typeface="Microsoft YaHei"/>
+              </a:defRPr>
+            </a:pPr>
+            <a:r>
+              <a:t>Macro F1 and the confusion matrix expose rare-mode limitations.</a:t>
+            </a:r>
+          </a:p>
+        </p:txBody>
+      </p:sp>
+      <p:pic>
+        <p:nvPicPr>
+          <p:cNvPr id="7" name="Picture 6" descr="xgboost_unweighted_test_confusion_matrix.png"/>
+          <p:cNvPicPr>
+            <a:picLocks noChangeAspect="1"/>
+          </p:cNvPicPr>
+          <p:nvPr/>
+        </p:nvPicPr>
+        <p:blipFill>
+          <a:blip r:embed="rId2"/>
+          <a:stretch>
+            <a:fillRect/>
+          </a:stretch>
+        </p:blipFill>
+        <p:spPr>
+          <a:xfrm>
+            <a:off x="6263640" y="1097280"/>
+            <a:ext cx="5257800" cy="4418295"/>
+          </a:xfrm>
+          <a:prstGeom prst="rect">
+            <a:avLst/>
+          </a:prstGeom>
+        </p:spPr>
+      </p:pic>
     </p:spTree>
   </p:cSld>
   <p:clrMapOvr>
@@ -4528,7 +4464,7 @@
               </a:defRPr>
             </a:pPr>
             <a:r>
-              <a:t>What the LLM contributes</a:t>
+              <a:t>Metric guide</a:t>
             </a:r>
           </a:p>
         </p:txBody>
@@ -4564,7 +4500,7 @@
               </a:defRPr>
             </a:pPr>
             <a:r>
-              <a:t>Event semantics, not direct numerical prediction</a:t>
+              <a:t>How to read the numbers</a:t>
             </a:r>
           </a:p>
         </p:txBody>
@@ -4605,16 +4541,427 @@
           </a:p>
         </p:txBody>
       </p:sp>
-      <p:sp>
-        <p:nvSpPr>
-          <p:cNvPr id="5" name="TextBox 4"/>
+      <p:graphicFrame>
+        <p:nvGraphicFramePr>
+          <p:cNvPr id="5" name="Table 4"/>
+          <p:cNvGraphicFramePr>
+            <a:graphicFrameLocks noGrp="1"/>
+          </p:cNvGraphicFramePr>
+          <p:nvPr/>
+        </p:nvGraphicFramePr>
+        <p:xfrm>
+          <a:off x="685800" y="1234440"/>
+          <a:ext cx="10789920" cy="3108960"/>
+        </p:xfrm>
+        <a:graphic>
+          <a:graphicData uri="http://schemas.openxmlformats.org/drawingml/2006/table">
+            <a:tbl>
+              <a:tblPr firstRow="1" bandRow="1">
+                <a:tableStyleId>{5C22544A-7EE6-4342-B048-85BDC9FD1C3A}</a:tableStyleId>
+              </a:tblPr>
+              <a:tblGrid>
+                <a:gridCol w="3596640"/>
+                <a:gridCol w="3596640"/>
+                <a:gridCol w="3596640"/>
+              </a:tblGrid>
+              <a:tr h="518160">
+                <a:tc>
+                  <a:txBody>
+                    <a:bodyPr/>
+                    <a:lstStyle/>
+                    <a:p>
+                      <a:pPr algn="l">
+                        <a:defRPr sz="1200" b="1">
+                          <a:solidFill>
+                            <a:srgbClr val="0F172A"/>
+                          </a:solidFill>
+                          <a:latin typeface="Microsoft YaHei"/>
+                        </a:defRPr>
+                      </a:pPr>
+                      <a:r>
+                        <a:t>Metric</a:t>
+                      </a:r>
+                    </a:p>
+                  </a:txBody>
+                  <a:tcPr marL="36576" marR="36576">
+                    <a:solidFill>
+                      <a:srgbClr val="E2E8F0"/>
+                    </a:solidFill>
+                  </a:tcPr>
+                </a:tc>
+                <a:tc>
+                  <a:txBody>
+                    <a:bodyPr/>
+                    <a:lstStyle/>
+                    <a:p>
+                      <a:pPr algn="ctr">
+                        <a:defRPr sz="1200" b="1">
+                          <a:solidFill>
+                            <a:srgbClr val="0F172A"/>
+                          </a:solidFill>
+                          <a:latin typeface="Microsoft YaHei"/>
+                        </a:defRPr>
+                      </a:pPr>
+                      <a:r>
+                        <a:t>Task</a:t>
+                      </a:r>
+                    </a:p>
+                  </a:txBody>
+                  <a:tcPr marL="36576" marR="36576">
+                    <a:solidFill>
+                      <a:srgbClr val="E2E8F0"/>
+                    </a:solidFill>
+                  </a:tcPr>
+                </a:tc>
+                <a:tc>
+                  <a:txBody>
+                    <a:bodyPr/>
+                    <a:lstStyle/>
+                    <a:p>
+                      <a:pPr algn="ctr">
+                        <a:defRPr sz="1200" b="1">
+                          <a:solidFill>
+                            <a:srgbClr val="0F172A"/>
+                          </a:solidFill>
+                          <a:latin typeface="Microsoft YaHei"/>
+                        </a:defRPr>
+                      </a:pPr>
+                      <a:r>
+                        <a:t>Meaning</a:t>
+                      </a:r>
+                    </a:p>
+                  </a:txBody>
+                  <a:tcPr marL="36576" marR="36576">
+                    <a:solidFill>
+                      <a:srgbClr val="E2E8F0"/>
+                    </a:solidFill>
+                  </a:tcPr>
+                </a:tc>
+              </a:tr>
+              <a:tr h="518160">
+                <a:tc>
+                  <a:txBody>
+                    <a:bodyPr/>
+                    <a:lstStyle/>
+                    <a:p>
+                      <a:pPr algn="l">
+                        <a:defRPr sz="1200" b="0">
+                          <a:solidFill>
+                            <a:srgbClr val="0F172A"/>
+                          </a:solidFill>
+                          <a:latin typeface="Microsoft YaHei"/>
+                        </a:defRPr>
+                      </a:pPr>
+                      <a:r>
+                        <a:t>Weighted MAE</a:t>
+                      </a:r>
+                    </a:p>
+                  </a:txBody>
+                  <a:tcPr marL="36576" marR="36576"/>
+                </a:tc>
+                <a:tc>
+                  <a:txBody>
+                    <a:bodyPr/>
+                    <a:lstStyle/>
+                    <a:p>
+                      <a:pPr algn="ctr">
+                        <a:defRPr sz="1200" b="0">
+                          <a:solidFill>
+                            <a:srgbClr val="0F172A"/>
+                          </a:solidFill>
+                          <a:latin typeface="Microsoft YaHei"/>
+                        </a:defRPr>
+                      </a:pPr>
+                      <a:r>
+                        <a:t>Trip count</a:t>
+                      </a:r>
+                    </a:p>
+                  </a:txBody>
+                  <a:tcPr marL="36576" marR="36576"/>
+                </a:tc>
+                <a:tc>
+                  <a:txBody>
+                    <a:bodyPr/>
+                    <a:lstStyle/>
+                    <a:p>
+                      <a:pPr algn="ctr">
+                        <a:defRPr sz="1200" b="0">
+                          <a:solidFill>
+                            <a:srgbClr val="0F172A"/>
+                          </a:solidFill>
+                          <a:latin typeface="Microsoft YaHei"/>
+                        </a:defRPr>
+                      </a:pPr>
+                      <a:r>
+                        <a:t>Average absolute trip-count error</a:t>
+                      </a:r>
+                    </a:p>
+                  </a:txBody>
+                  <a:tcPr marL="36576" marR="36576"/>
+                </a:tc>
+              </a:tr>
+              <a:tr h="518160">
+                <a:tc>
+                  <a:txBody>
+                    <a:bodyPr/>
+                    <a:lstStyle/>
+                    <a:p>
+                      <a:pPr algn="l">
+                        <a:defRPr sz="1200" b="0">
+                          <a:solidFill>
+                            <a:srgbClr val="0F172A"/>
+                          </a:solidFill>
+                          <a:latin typeface="Microsoft YaHei"/>
+                        </a:defRPr>
+                      </a:pPr>
+                      <a:r>
+                        <a:t>Weighted Bias</a:t>
+                      </a:r>
+                    </a:p>
+                  </a:txBody>
+                  <a:tcPr marL="36576" marR="36576"/>
+                </a:tc>
+                <a:tc>
+                  <a:txBody>
+                    <a:bodyPr/>
+                    <a:lstStyle/>
+                    <a:p>
+                      <a:pPr algn="ctr">
+                        <a:defRPr sz="1200" b="0">
+                          <a:solidFill>
+                            <a:srgbClr val="0F172A"/>
+                          </a:solidFill>
+                          <a:latin typeface="Microsoft YaHei"/>
+                        </a:defRPr>
+                      </a:pPr>
+                      <a:r>
+                        <a:t>Trip count</a:t>
+                      </a:r>
+                    </a:p>
+                  </a:txBody>
+                  <a:tcPr marL="36576" marR="36576"/>
+                </a:tc>
+                <a:tc>
+                  <a:txBody>
+                    <a:bodyPr/>
+                    <a:lstStyle/>
+                    <a:p>
+                      <a:pPr algn="ctr">
+                        <a:defRPr sz="1200" b="0">
+                          <a:solidFill>
+                            <a:srgbClr val="0F172A"/>
+                          </a:solidFill>
+                          <a:latin typeface="Microsoft YaHei"/>
+                        </a:defRPr>
+                      </a:pPr>
+                      <a:r>
+                        <a:t>Systematic over/under prediction</a:t>
+                      </a:r>
+                    </a:p>
+                  </a:txBody>
+                  <a:tcPr marL="36576" marR="36576"/>
+                </a:tc>
+              </a:tr>
+              <a:tr h="518160">
+                <a:tc>
+                  <a:txBody>
+                    <a:bodyPr/>
+                    <a:lstStyle/>
+                    <a:p>
+                      <a:pPr algn="l">
+                        <a:defRPr sz="1200" b="0">
+                          <a:solidFill>
+                            <a:srgbClr val="0F172A"/>
+                          </a:solidFill>
+                          <a:latin typeface="Microsoft YaHei"/>
+                        </a:defRPr>
+                      </a:pPr>
+                      <a:r>
+                        <a:t>Within-k</a:t>
+                      </a:r>
+                    </a:p>
+                  </a:txBody>
+                  <a:tcPr marL="36576" marR="36576"/>
+                </a:tc>
+                <a:tc>
+                  <a:txBody>
+                    <a:bodyPr/>
+                    <a:lstStyle/>
+                    <a:p>
+                      <a:pPr algn="ctr">
+                        <a:defRPr sz="1200" b="0">
+                          <a:solidFill>
+                            <a:srgbClr val="0F172A"/>
+                          </a:solidFill>
+                          <a:latin typeface="Microsoft YaHei"/>
+                        </a:defRPr>
+                      </a:pPr>
+                      <a:r>
+                        <a:t>Trip count</a:t>
+                      </a:r>
+                    </a:p>
+                  </a:txBody>
+                  <a:tcPr marL="36576" marR="36576"/>
+                </a:tc>
+                <a:tc>
+                  <a:txBody>
+                    <a:bodyPr/>
+                    <a:lstStyle/>
+                    <a:p>
+                      <a:pPr algn="ctr">
+                        <a:defRPr sz="1200" b="0">
+                          <a:solidFill>
+                            <a:srgbClr val="0F172A"/>
+                          </a:solidFill>
+                          <a:latin typeface="Microsoft YaHei"/>
+                        </a:defRPr>
+                      </a:pPr>
+                      <a:r>
+                        <a:t>Households within k trips</a:t>
+                      </a:r>
+                    </a:p>
+                  </a:txBody>
+                  <a:tcPr marL="36576" marR="36576"/>
+                </a:tc>
+              </a:tr>
+              <a:tr h="518160">
+                <a:tc>
+                  <a:txBody>
+                    <a:bodyPr/>
+                    <a:lstStyle/>
+                    <a:p>
+                      <a:pPr algn="l">
+                        <a:defRPr sz="1200" b="0">
+                          <a:solidFill>
+                            <a:srgbClr val="0F172A"/>
+                          </a:solidFill>
+                          <a:latin typeface="Microsoft YaHei"/>
+                        </a:defRPr>
+                      </a:pPr>
+                      <a:r>
+                        <a:t>Weighted TV</a:t>
+                      </a:r>
+                    </a:p>
+                  </a:txBody>
+                  <a:tcPr marL="36576" marR="36576"/>
+                </a:tc>
+                <a:tc>
+                  <a:txBody>
+                    <a:bodyPr/>
+                    <a:lstStyle/>
+                    <a:p>
+                      <a:pPr algn="ctr">
+                        <a:defRPr sz="1200" b="0">
+                          <a:solidFill>
+                            <a:srgbClr val="0F172A"/>
+                          </a:solidFill>
+                          <a:latin typeface="Microsoft YaHei"/>
+                        </a:defRPr>
+                      </a:pPr>
+                      <a:r>
+                        <a:t>Mode composition</a:t>
+                      </a:r>
+                    </a:p>
+                  </a:txBody>
+                  <a:tcPr marL="36576" marR="36576"/>
+                </a:tc>
+                <a:tc>
+                  <a:txBody>
+                    <a:bodyPr/>
+                    <a:lstStyle/>
+                    <a:p>
+                      <a:pPr algn="ctr">
+                        <a:defRPr sz="1200" b="0">
+                          <a:solidFill>
+                            <a:srgbClr val="0F172A"/>
+                          </a:solidFill>
+                          <a:latin typeface="Microsoft YaHei"/>
+                        </a:defRPr>
+                      </a:pPr>
+                      <a:r>
+                        <a:t>Whole share-vector error</a:t>
+                      </a:r>
+                    </a:p>
+                  </a:txBody>
+                  <a:tcPr marL="36576" marR="36576"/>
+                </a:tc>
+              </a:tr>
+              <a:tr h="518160">
+                <a:tc>
+                  <a:txBody>
+                    <a:bodyPr/>
+                    <a:lstStyle/>
+                    <a:p>
+                      <a:pPr algn="l">
+                        <a:defRPr sz="1200" b="0">
+                          <a:solidFill>
+                            <a:srgbClr val="0F172A"/>
+                          </a:solidFill>
+                          <a:latin typeface="Microsoft YaHei"/>
+                        </a:defRPr>
+                      </a:pPr>
+                      <a:r>
+                        <a:t>Transit-share MAE</a:t>
+                      </a:r>
+                    </a:p>
+                  </a:txBody>
+                  <a:tcPr marL="36576" marR="36576"/>
+                </a:tc>
+                <a:tc>
+                  <a:txBody>
+                    <a:bodyPr/>
+                    <a:lstStyle/>
+                    <a:p>
+                      <a:pPr algn="ctr">
+                        <a:defRPr sz="1200" b="0">
+                          <a:solidFill>
+                            <a:srgbClr val="0F172A"/>
+                          </a:solidFill>
+                          <a:latin typeface="Microsoft YaHei"/>
+                        </a:defRPr>
+                      </a:pPr>
+                      <a:r>
+                        <a:t>Mode composition</a:t>
+                      </a:r>
+                    </a:p>
+                  </a:txBody>
+                  <a:tcPr marL="36576" marR="36576"/>
+                </a:tc>
+                <a:tc>
+                  <a:txBody>
+                    <a:bodyPr/>
+                    <a:lstStyle/>
+                    <a:p>
+                      <a:pPr algn="ctr">
+                        <a:defRPr sz="1200" b="0">
+                          <a:solidFill>
+                            <a:srgbClr val="0F172A"/>
+                          </a:solidFill>
+                          <a:latin typeface="Microsoft YaHei"/>
+                        </a:defRPr>
+                      </a:pPr>
+                      <a:r>
+                        <a:t>Public-transit share error</a:t>
+                      </a:r>
+                    </a:p>
+                  </a:txBody>
+                  <a:tcPr marL="36576" marR="36576"/>
+                </a:tc>
+              </a:tr>
+            </a:tbl>
+          </a:graphicData>
+        </a:graphic>
+      </p:graphicFrame>
+      <p:sp>
+        <p:nvSpPr>
+          <p:cNvPr id="6" name="TextBox 5"/>
           <p:cNvSpPr txBox="1"/>
           <p:nvPr/>
         </p:nvSpPr>
         <p:spPr>
           <a:xfrm>
-            <a:off x="868680" y="1325880"/>
-            <a:ext cx="10149840" cy="4297680"/>
+            <a:off x="914400" y="4846320"/>
+            <a:ext cx="10058400" cy="640080"/>
           </a:xfrm>
           <a:prstGeom prst="rect">
             <a:avLst/>
@@ -4631,7 +4978,7 @@
               <a:spcAft>
                 <a:spcPts val="800"/>
               </a:spcAft>
-              <a:defRPr sz="2200" b="0">
+              <a:defRPr sz="1800" b="0">
                 <a:solidFill>
                   <a:srgbClr val="0F172A"/>
                 </a:solidFill>
@@ -4639,71 +4986,7 @@
               </a:defRPr>
             </a:pPr>
             <a:r>
-              <a:t>The historical predictor learns routine household mobility from NHTS.</a:t>
-            </a:r>
-          </a:p>
-          <a:p>
-            <a:pPr>
-              <a:spcAft>
-                <a:spcPts val="800"/>
-              </a:spcAft>
-              <a:defRPr sz="2200" b="0">
-                <a:solidFill>
-                  <a:srgbClr val="0F172A"/>
-                </a:solidFill>
-                <a:latin typeface="Microsoft YaHei"/>
-              </a:defRPr>
-            </a:pPr>
-            <a:r>
-              <a:t>The LLM supplies post-pandemic event priors: trip suppression, remote work, transit avoidance, delivery substitution, recovery sensitivity.</a:t>
-            </a:r>
-          </a:p>
-          <a:p>
-            <a:pPr>
-              <a:spcAft>
-                <a:spcPts val="800"/>
-              </a:spcAft>
-              <a:defRPr sz="2200" b="0">
-                <a:solidFill>
-                  <a:srgbClr val="0F172A"/>
-                </a:solidFill>
-                <a:latin typeface="Microsoft YaHei"/>
-              </a:defRPr>
-            </a:pPr>
-            <a:r>
-              <a:t>The LLM-only pressure baseline improves over naive history but is weaker than the hybrid model.</a:t>
-            </a:r>
-          </a:p>
-          <a:p>
-            <a:pPr>
-              <a:spcAft>
-                <a:spcPts val="800"/>
-              </a:spcAft>
-              <a:defRPr sz="2200" b="0">
-                <a:solidFill>
-                  <a:srgbClr val="0F172A"/>
-                </a:solidFill>
-                <a:latin typeface="Microsoft YaHei"/>
-              </a:defRPr>
-            </a:pPr>
-            <a:r>
-              <a:t>Global controls show that broad event downscaling is strong.</a:t>
-            </a:r>
-          </a:p>
-          <a:p>
-            <a:pPr>
-              <a:spcAft>
-                <a:spcPts val="800"/>
-              </a:spcAft>
-              <a:defRPr sz="2200" b="0">
-                <a:solidFill>
-                  <a:srgbClr val="0F172A"/>
-                </a:solidFill>
-                <a:latin typeface="Microsoft YaHei"/>
-              </a:defRPr>
-            </a:pPr>
-            <a:r>
-              <a:t>Random controls and subgroup diagnostics show that cohort-specific LLM ranking adds smaller but measurable signal.</a:t>
+              <a:t>Lower is better for errors; bias closer to zero is better; R2 and accuracy are higher-is-better.</a:t>
             </a:r>
           </a:p>
         </p:txBody>
@@ -4765,7 +5048,7 @@
               </a:defRPr>
             </a:pPr>
             <a:r>
-              <a:t>Caveats</a:t>
+              <a:t>What the LLM contributes</a:t>
             </a:r>
           </a:p>
         </p:txBody>
@@ -4801,7 +5084,7 @@
               </a:defRPr>
             </a:pPr>
             <a:r>
-              <a:t>What we should not overclaim</a:t>
+              <a:t>Event semantics, not direct numerical prediction</a:t>
             </a:r>
           </a:p>
         </p:txBody>
@@ -4868,7 +5151,7 @@
               <a:spcAft>
                 <a:spcPts val="800"/>
               </a:spcAft>
-              <a:defRPr sz="2300" b="0">
+              <a:defRPr sz="2200" b="0">
                 <a:solidFill>
                   <a:srgbClr val="0F172A"/>
                 </a:solidFill>
@@ -4876,7 +5159,7 @@
               </a:defRPr>
             </a:pPr>
             <a:r>
-              <a:t>Do not claim that LLM directly predicts household trip counts.</a:t>
+              <a:t>The historical predictor learns routine household mobility from NHTS.</a:t>
             </a:r>
           </a:p>
           <a:p>
@@ -4884,7 +5167,7 @@
               <a:spcAft>
                 <a:spcPts val="800"/>
               </a:spcAft>
-              <a:defRPr sz="2300" b="0">
+              <a:defRPr sz="2200" b="0">
                 <a:solidFill>
                   <a:srgbClr val="0F172A"/>
                 </a:solidFill>
@@ -4892,7 +5175,7 @@
               </a:defRPr>
             </a:pPr>
             <a:r>
-              <a:t>Keep parameter-sweep sensitivity rows in appendix/internal analysis, not in the main comparison.</a:t>
+              <a:t>The LLM supplies post-pandemic event priors: trip suppression, remote work, transit avoidance, delivery substitution, recovery sensitivity.</a:t>
             </a:r>
           </a:p>
           <a:p>
@@ -4900,7 +5183,7 @@
               <a:spcAft>
                 <a:spcPts val="800"/>
               </a:spcAft>
-              <a:defRPr sz="2300" b="0">
+              <a:defRPr sz="2200" b="0">
                 <a:solidFill>
                   <a:srgbClr val="0F172A"/>
                 </a:solidFill>
@@ -4908,7 +5191,7 @@
               </a:defRPr>
             </a:pPr>
             <a:r>
-              <a:t>Present trip generation and mode composition as two household-level outputs, not as separate projects.</a:t>
+              <a:t>The LLM-only pressure baseline improves over naive history but is weaker than the hybrid model.</a:t>
             </a:r>
           </a:p>
           <a:p>
@@ -4916,7 +5199,7 @@
               <a:spcAft>
                 <a:spcPts val="800"/>
               </a:spcAft>
-              <a:defRPr sz="2300" b="0">
+              <a:defRPr sz="2200" b="0">
                 <a:solidFill>
                   <a:srgbClr val="0F172A"/>
                 </a:solidFill>
@@ -4924,7 +5207,7 @@
               </a:defRPr>
             </a:pPr>
             <a:r>
-              <a:t>Mode composition is weaker overall than trip-count adaptation, but it adds the mode-structure dimension.</a:t>
+              <a:t>Global controls show that broad event downscaling is strong.</a:t>
             </a:r>
           </a:p>
           <a:p>
@@ -4932,7 +5215,7 @@
               <a:spcAft>
                 <a:spcPts val="800"/>
               </a:spcAft>
-              <a:defRPr sz="2300" b="0">
+              <a:defRPr sz="2200" b="0">
                 <a:solidFill>
                   <a:srgbClr val="0F172A"/>
                 </a:solidFill>
@@ -4940,7 +5223,7 @@
               </a:defRPr>
             </a:pPr>
             <a:r>
-              <a:t>Future work should add external event context, stronger LLM priors, and prospective validation.</a:t>
+              <a:t>Random controls and subgroup diagnostics show that cohort-specific LLM ranking adds smaller but measurable signal.</a:t>
             </a:r>
           </a:p>
         </p:txBody>
@@ -5002,7 +5285,7 @@
               </a:defRPr>
             </a:pPr>
             <a:r>
-              <a:t>Final takeaway</a:t>
+              <a:t>Caveats</a:t>
             </a:r>
           </a:p>
         </p:txBody>
@@ -5038,7 +5321,7 @@
               </a:defRPr>
             </a:pPr>
             <a:r>
-              <a:t>A defensible story for the course project</a:t>
+              <a:t>What we should not overclaim</a:t>
             </a:r>
           </a:p>
         </p:txBody>
@@ -5075,6 +5358,243 @@
             </a:pPr>
             <a:r>
               <a:t>NHTS LLM Event Adaptation | 15</a:t>
+            </a:r>
+          </a:p>
+        </p:txBody>
+      </p:sp>
+      <p:sp>
+        <p:nvSpPr>
+          <p:cNvPr id="5" name="TextBox 4"/>
+          <p:cNvSpPr txBox="1"/>
+          <p:nvPr/>
+        </p:nvSpPr>
+        <p:spPr>
+          <a:xfrm>
+            <a:off x="868680" y="1325880"/>
+            <a:ext cx="10149840" cy="4297680"/>
+          </a:xfrm>
+          <a:prstGeom prst="rect">
+            <a:avLst/>
+          </a:prstGeom>
+          <a:noFill/>
+        </p:spPr>
+        <p:txBody>
+          <a:bodyPr wrap="square">
+            <a:spAutoFit/>
+          </a:bodyPr>
+          <a:lstStyle/>
+          <a:p>
+            <a:pPr>
+              <a:spcAft>
+                <a:spcPts val="800"/>
+              </a:spcAft>
+              <a:defRPr sz="2300" b="0">
+                <a:solidFill>
+                  <a:srgbClr val="0F172A"/>
+                </a:solidFill>
+                <a:latin typeface="Microsoft YaHei"/>
+              </a:defRPr>
+            </a:pPr>
+            <a:r>
+              <a:t>Do not claim that LLM directly predicts household trip counts.</a:t>
+            </a:r>
+          </a:p>
+          <a:p>
+            <a:pPr>
+              <a:spcAft>
+                <a:spcPts val="800"/>
+              </a:spcAft>
+              <a:defRPr sz="2300" b="0">
+                <a:solidFill>
+                  <a:srgbClr val="0F172A"/>
+                </a:solidFill>
+                <a:latin typeface="Microsoft YaHei"/>
+              </a:defRPr>
+            </a:pPr>
+            <a:r>
+              <a:t>Keep parameter-sweep sensitivity rows in appendix/internal analysis, not in the main comparison.</a:t>
+            </a:r>
+          </a:p>
+          <a:p>
+            <a:pPr>
+              <a:spcAft>
+                <a:spcPts val="800"/>
+              </a:spcAft>
+              <a:defRPr sz="2300" b="0">
+                <a:solidFill>
+                  <a:srgbClr val="0F172A"/>
+                </a:solidFill>
+                <a:latin typeface="Microsoft YaHei"/>
+              </a:defRPr>
+            </a:pPr>
+            <a:r>
+              <a:t>Present trip generation and mode composition as two household-level outputs, not as separate projects.</a:t>
+            </a:r>
+          </a:p>
+          <a:p>
+            <a:pPr>
+              <a:spcAft>
+                <a:spcPts val="800"/>
+              </a:spcAft>
+              <a:defRPr sz="2300" b="0">
+                <a:solidFill>
+                  <a:srgbClr val="0F172A"/>
+                </a:solidFill>
+                <a:latin typeface="Microsoft YaHei"/>
+              </a:defRPr>
+            </a:pPr>
+            <a:r>
+              <a:t>Mode composition and trip-level mode choice add behavior-system evidence, but rare modes remain harder.</a:t>
+            </a:r>
+          </a:p>
+          <a:p>
+            <a:pPr>
+              <a:spcAft>
+                <a:spcPts val="800"/>
+              </a:spcAft>
+              <a:defRPr sz="2300" b="0">
+                <a:solidFill>
+                  <a:srgbClr val="0F172A"/>
+                </a:solidFill>
+                <a:latin typeface="Microsoft YaHei"/>
+              </a:defRPr>
+            </a:pPr>
+            <a:r>
+              <a:t>Future work should add external event context, stronger LLM priors, and prospective validation.</a:t>
+            </a:r>
+          </a:p>
+        </p:txBody>
+      </p:sp>
+    </p:spTree>
+  </p:cSld>
+  <p:clrMapOvr>
+    <a:masterClrMapping/>
+  </p:clrMapOvr>
+</p:sld>
+</file>
+
+<file path=ppt/slides/slide16.xml><?xml version="1.0" encoding="utf-8"?>
+<p:sld xmlns:a="http://schemas.openxmlformats.org/drawingml/2006/main" xmlns:p="http://schemas.openxmlformats.org/presentationml/2006/main" xmlns:r="http://schemas.openxmlformats.org/officeDocument/2006/relationships">
+  <p:cSld>
+    <p:bg>
+      <p:bgPr>
+        <a:solidFill>
+          <a:srgbClr val="FFFFFF"/>
+        </a:solidFill>
+        <a:effectLst/>
+      </p:bgPr>
+    </p:bg>
+    <p:spTree>
+      <p:nvGrpSpPr>
+        <p:cNvPr id="1" name=""/>
+        <p:cNvGrpSpPr/>
+        <p:nvPr/>
+      </p:nvGrpSpPr>
+      <p:grpSpPr/>
+      <p:sp>
+        <p:nvSpPr>
+          <p:cNvPr id="2" name="TextBox 1"/>
+          <p:cNvSpPr txBox="1"/>
+          <p:nvPr/>
+        </p:nvSpPr>
+        <p:spPr>
+          <a:xfrm>
+            <a:off x="502920" y="256032"/>
+            <a:ext cx="11155680" cy="502920"/>
+          </a:xfrm>
+          <a:prstGeom prst="rect">
+            <a:avLst/>
+          </a:prstGeom>
+          <a:noFill/>
+        </p:spPr>
+        <p:txBody>
+          <a:bodyPr wrap="none">
+            <a:spAutoFit/>
+          </a:bodyPr>
+          <a:lstStyle/>
+          <a:p>
+            <a:pPr>
+              <a:defRPr sz="2700" b="1">
+                <a:solidFill>
+                  <a:srgbClr val="0F172A"/>
+                </a:solidFill>
+                <a:latin typeface="Microsoft YaHei"/>
+              </a:defRPr>
+            </a:pPr>
+            <a:r>
+              <a:t>Final takeaway</a:t>
+            </a:r>
+          </a:p>
+        </p:txBody>
+      </p:sp>
+      <p:sp>
+        <p:nvSpPr>
+          <p:cNvPr id="3" name="TextBox 2"/>
+          <p:cNvSpPr txBox="1"/>
+          <p:nvPr/>
+        </p:nvSpPr>
+        <p:spPr>
+          <a:xfrm>
+            <a:off x="530352" y="786384"/>
+            <a:ext cx="10972800" cy="347472"/>
+          </a:xfrm>
+          <a:prstGeom prst="rect">
+            <a:avLst/>
+          </a:prstGeom>
+          <a:noFill/>
+        </p:spPr>
+        <p:txBody>
+          <a:bodyPr wrap="none">
+            <a:spAutoFit/>
+          </a:bodyPr>
+          <a:lstStyle/>
+          <a:p>
+            <a:pPr>
+              <a:defRPr sz="1300" b="0">
+                <a:solidFill>
+                  <a:srgbClr val="475569"/>
+                </a:solidFill>
+                <a:latin typeface="Microsoft YaHei"/>
+              </a:defRPr>
+            </a:pPr>
+            <a:r>
+              <a:t>A defensible story for the course project</a:t>
+            </a:r>
+          </a:p>
+        </p:txBody>
+      </p:sp>
+      <p:sp>
+        <p:nvSpPr>
+          <p:cNvPr id="4" name="TextBox 3"/>
+          <p:cNvSpPr txBox="1"/>
+          <p:nvPr/>
+        </p:nvSpPr>
+        <p:spPr>
+          <a:xfrm>
+            <a:off x="502920" y="6473952"/>
+            <a:ext cx="10972800" cy="201168"/>
+          </a:xfrm>
+          <a:prstGeom prst="rect">
+            <a:avLst/>
+          </a:prstGeom>
+          <a:noFill/>
+        </p:spPr>
+        <p:txBody>
+          <a:bodyPr wrap="none">
+            <a:spAutoFit/>
+          </a:bodyPr>
+          <a:lstStyle/>
+          <a:p>
+            <a:pPr>
+              <a:defRPr sz="900" b="0">
+                <a:solidFill>
+                  <a:srgbClr val="64748B"/>
+                </a:solidFill>
+                <a:latin typeface="Microsoft YaHei"/>
+              </a:defRPr>
+            </a:pPr>
+            <a:r>
+              <a:t>NHTS LLM Event Adaptation | 16</a:t>
             </a:r>
           </a:p>
         </p:txBody>

</xml_diff>

<commit_message>
feat(mode-choice): add survey-weighted transfer evaluation
</commit_message>
<xml_diff>
--- a/outputs/final_project/NHTS_LLM_Event_Adaptation_Optimized_Presentation.pptx
+++ b/outputs/final_project/NHTS_LLM_Event_Adaptation_Optimized_Presentation.pptx
@@ -4085,7 +4085,7 @@
                         </a:defRPr>
                       </a:pPr>
                       <a:r>
-                        <a:t>Accuracy</a:t>
+                        <a:t>Weighted acc.</a:t>
                       </a:r>
                     </a:p>
                   </a:txBody>
@@ -4109,7 +4109,7 @@
                         </a:defRPr>
                       </a:pPr>
                       <a:r>
-                        <a:t>Balanced acc.</a:t>
+                        <a:t>W-balanced acc.</a:t>
                       </a:r>
                     </a:p>
                   </a:txBody>
@@ -4133,7 +4133,7 @@
                         </a:defRPr>
                       </a:pPr>
                       <a:r>
-                        <a:t>Macro F1</a:t>
+                        <a:t>W-macro F1</a:t>
                       </a:r>
                     </a:p>
                   </a:txBody>
@@ -4159,7 +4159,7 @@
                         </a:defRPr>
                       </a:pPr>
                       <a:r>
-                        <a:t>XGBoost</a:t>
+                        <a:t>Survey-weighted XGB</a:t>
                       </a:r>
                     </a:p>
                   </a:txBody>
@@ -4179,7 +4179,7 @@
                         </a:defRPr>
                       </a:pPr>
                       <a:r>
-                        <a:t>0.9373</a:t>
+                        <a:t>0.9297</a:t>
                       </a:r>
                     </a:p>
                   </a:txBody>
@@ -4199,7 +4199,7 @@
                         </a:defRPr>
                       </a:pPr>
                       <a:r>
-                        <a:t>0.4309</a:t>
+                        <a:t>0.4343</a:t>
                       </a:r>
                     </a:p>
                   </a:txBody>
@@ -4219,7 +4219,7 @@
                         </a:defRPr>
                       </a:pPr>
                       <a:r>
-                        <a:t>0.4658</a:t>
+                        <a:t>0.4663</a:t>
                       </a:r>
                     </a:p>
                   </a:txBody>
@@ -4261,7 +4261,7 @@
                         </a:defRPr>
                       </a:pPr>
                       <a:r>
-                        <a:t>0.6758</a:t>
+                        <a:t>0.7852</a:t>
                       </a:r>
                     </a:p>
                   </a:txBody>
@@ -4281,7 +4281,7 @@
                         </a:defRPr>
                       </a:pPr>
                       <a:r>
-                        <a:t>0.6167</a:t>
+                        <a:t>0.5501</a:t>
                       </a:r>
                     </a:p>
                   </a:txBody>
@@ -4301,7 +4301,7 @@
                         </a:defRPr>
                       </a:pPr>
                       <a:r>
-                        <a:t>0.3553</a:t>
+                        <a:t>0.3722</a:t>
                       </a:r>
                     </a:p>
                   </a:txBody>
@@ -4385,7 +4385,7 @@
       </p:sp>
       <p:pic>
         <p:nvPicPr>
-          <p:cNvPr id="7" name="Picture 6" descr="xgboost_unweighted_test_confusion_matrix.png"/>
+          <p:cNvPr id="7" name="Picture 6" descr="xgboost_survey_weighted_test_confusion_matrix.png"/>
           <p:cNvPicPr>
             <a:picLocks noChangeAspect="1"/>
           </p:cNvPicPr>

</xml_diff>